<commit_message>
Redesign component diagram as data flow diagram with angular arrows
- Angular/elbow connectors (ctype=2) throughout
- Numbered sequence badges ①–⑦ on each arrow
- Embedding model (all-MiniLM-L6-v2) shown as explicit component
- Data values shown on each arrow via 2-column legend
- "LLM not used" annotation: explains replacement of embedding API
  and answer-generation API with local model + Copilot-as-LLM
- seq_badge() helper added; conn() gains ctype parameter

Co-Authored-By: Claude Sonnet 4.6 <noreply@anthropic.com>
</commit_message>
<xml_diff>
--- a/demo/slides.pptx
+++ b/demo/slides.pptx
@@ -15092,8 +15092,8 @@
         </p:nvSpPr>
         <p:spPr>
           <a:xfrm>
-            <a:off x="365760" y="137160"/>
-            <a:ext cx="11430000" cy="256032"/>
+            <a:off x="365760" y="91440"/>
+            <a:ext cx="11430000" cy="228600"/>
           </a:xfrm>
           <a:prstGeom prst="rect">
             <a:avLst/>
@@ -15113,7 +15113,7 @@
                   <a:srgbClr val="58A6FF"/>
                 </a:solidFill>
               </a:rPr>
-              <a:t>COMPONENT DIAGRAM</a:t>
+              <a:t>DATA FLOW DIAGRAM</a:t>
             </a:r>
           </a:p>
         </p:txBody>
@@ -15126,7 +15126,7 @@
         </p:nvSpPr>
         <p:spPr>
           <a:xfrm>
-            <a:off x="365760" y="411480"/>
+            <a:off x="365760" y="338328"/>
             <a:ext cx="11430000" cy="365760"/>
           </a:xfrm>
           <a:prstGeom prst="rect">
@@ -15142,12 +15142,12 @@
           <a:p>
             <a:pPr algn="ctr"/>
             <a:r>
-              <a:rPr sz="2200" b="1">
+              <a:rPr sz="1900" b="1">
                 <a:solidFill>
                   <a:srgbClr val="F0F6FC"/>
                 </a:solidFill>
               </a:rPr>
-              <a:t>MCP Tool Calling &amp; RAG Knowledge Pipeline</a:t>
+              <a:t>Agentic Orchestration — Components, Interfaces &amp; Data Flow</a:t>
             </a:r>
           </a:p>
         </p:txBody>
@@ -15160,8 +15160,8 @@
         </p:nvSpPr>
         <p:spPr>
           <a:xfrm>
-            <a:off x="4206240" y="841248"/>
-            <a:ext cx="2743200" cy="502920"/>
+            <a:off x="3931920" y="758952"/>
+            <a:ext cx="3291840" cy="566928"/>
           </a:xfrm>
           <a:prstGeom prst="rect">
             <a:avLst/>
@@ -15205,8 +15205,8 @@
         </p:nvSpPr>
         <p:spPr>
           <a:xfrm>
-            <a:off x="4233672" y="877824"/>
-            <a:ext cx="2688336" cy="420624"/>
+            <a:off x="3977639" y="832103"/>
+            <a:ext cx="3200400" cy="420623"/>
           </a:xfrm>
           <a:prstGeom prst="rect">
             <a:avLst/>
@@ -15226,7 +15226,7 @@
                   <a:srgbClr val="BC8CFF"/>
                 </a:solidFill>
               </a:rPr>
-              <a:t>GitHub Copilot  (Agent Mode)</a:t>
+              <a:t>GitHub Copilot  (Agent Mode  ·  LLM)</a:t>
             </a:r>
           </a:p>
         </p:txBody>
@@ -15239,8 +15239,8 @@
         </p:nvSpPr>
         <p:spPr>
           <a:xfrm>
-            <a:off x="274320" y="1965960"/>
-            <a:ext cx="2606040" cy="822960"/>
+            <a:off x="182880" y="1965960"/>
+            <a:ext cx="2651760" cy="822960"/>
           </a:xfrm>
           <a:prstGeom prst="rect">
             <a:avLst/>
@@ -15284,8 +15284,8 @@
         </p:nvSpPr>
         <p:spPr>
           <a:xfrm>
-            <a:off x="310896" y="2020824"/>
-            <a:ext cx="2532888" cy="713232"/>
+            <a:off x="228600" y="2039112"/>
+            <a:ext cx="2560320" cy="676656"/>
           </a:xfrm>
           <a:prstGeom prst="rect">
             <a:avLst/>
@@ -15307,7 +15307,7 @@
               </a:rPr>
               <a:t>Orchestrator
 router_mcp_server.py
-« get_relevant_repos »</a:t>
+get_relevant_repos</a:t>
             </a:r>
           </a:p>
         </p:txBody>
@@ -15320,8 +15320,8 @@
         </p:nvSpPr>
         <p:spPr>
           <a:xfrm>
-            <a:off x="3520440" y="1371600"/>
-            <a:ext cx="2560320" cy="566928"/>
+            <a:off x="3200400" y="1389888"/>
+            <a:ext cx="2560320" cy="594360"/>
           </a:xfrm>
           <a:prstGeom prst="rect">
             <a:avLst/>
@@ -15365,8 +15365,8 @@
         </p:nvSpPr>
         <p:spPr>
           <a:xfrm>
-            <a:off x="3547872" y="1408176"/>
-            <a:ext cx="2505456" cy="256032"/>
+            <a:off x="3246120" y="1426464"/>
+            <a:ext cx="2468879" cy="256032"/>
           </a:xfrm>
           <a:prstGeom prst="rect">
             <a:avLst/>
@@ -15399,28 +15399,28 @@
         </p:nvSpPr>
         <p:spPr>
           <a:xfrm>
-            <a:off x="3547872" y="1682496"/>
-            <a:ext cx="2505456" cy="201168"/>
-          </a:xfrm>
-          <a:prstGeom prst="rect">
-            <a:avLst/>
-          </a:prstGeom>
-          <a:noFill/>
-        </p:spPr>
-        <p:txBody>
-          <a:bodyPr wrap="square">
-            <a:spAutoFit/>
-          </a:bodyPr>
-          <a:lstStyle/>
-          <a:p>
-            <a:pPr algn="ctr"/>
-            <a:r>
-              <a:rPr sz="900" b="0">
+            <a:off x="3246120" y="1728216"/>
+            <a:ext cx="2468879" cy="182880"/>
+          </a:xfrm>
+          <a:prstGeom prst="rect">
+            <a:avLst/>
+          </a:prstGeom>
+          <a:noFill/>
+        </p:spPr>
+        <p:txBody>
+          <a:bodyPr wrap="square">
+            <a:spAutoFit/>
+          </a:bodyPr>
+          <a:lstStyle/>
+          <a:p>
+            <a:pPr algn="ctr"/>
+            <a:r>
+              <a:rPr sz="800" b="0">
                 <a:solidFill>
                   <a:srgbClr val="58A6FF"/>
                 </a:solidFill>
               </a:rPr>
-              <a:t>mcp_server.py  « query_repo »</a:t>
+              <a:t>mcp_server.py  ·  query_repo</a:t>
             </a:r>
           </a:p>
         </p:txBody>
@@ -15433,8 +15433,8 @@
         </p:nvSpPr>
         <p:spPr>
           <a:xfrm>
-            <a:off x="3520440" y="2286000"/>
-            <a:ext cx="2560320" cy="566928"/>
+            <a:off x="3200400" y="2331720"/>
+            <a:ext cx="2560320" cy="594360"/>
           </a:xfrm>
           <a:prstGeom prst="rect">
             <a:avLst/>
@@ -15478,8 +15478,8 @@
         </p:nvSpPr>
         <p:spPr>
           <a:xfrm>
-            <a:off x="3547872" y="2322576"/>
-            <a:ext cx="2505456" cy="256032"/>
+            <a:off x="3246120" y="2368296"/>
+            <a:ext cx="2468879" cy="256032"/>
           </a:xfrm>
           <a:prstGeom prst="rect">
             <a:avLst/>
@@ -15512,28 +15512,28 @@
         </p:nvSpPr>
         <p:spPr>
           <a:xfrm>
-            <a:off x="3547872" y="2596896"/>
-            <a:ext cx="2505456" cy="201168"/>
-          </a:xfrm>
-          <a:prstGeom prst="rect">
-            <a:avLst/>
-          </a:prstGeom>
-          <a:noFill/>
-        </p:spPr>
-        <p:txBody>
-          <a:bodyPr wrap="square">
-            <a:spAutoFit/>
-          </a:bodyPr>
-          <a:lstStyle/>
-          <a:p>
-            <a:pPr algn="ctr"/>
-            <a:r>
-              <a:rPr sz="900" b="0">
+            <a:off x="3246120" y="2670048"/>
+            <a:ext cx="2468879" cy="182880"/>
+          </a:xfrm>
+          <a:prstGeom prst="rect">
+            <a:avLst/>
+          </a:prstGeom>
+          <a:noFill/>
+        </p:spPr>
+        <p:txBody>
+          <a:bodyPr wrap="square">
+            <a:spAutoFit/>
+          </a:bodyPr>
+          <a:lstStyle/>
+          <a:p>
+            <a:pPr algn="ctr"/>
+            <a:r>
+              <a:rPr sz="800" b="0">
                 <a:solidFill>
                   <a:srgbClr val="58A6FF"/>
                 </a:solidFill>
               </a:rPr>
-              <a:t>mcp_server.py  « query_repo »</a:t>
+              <a:t>mcp_server.py  ·  query_repo</a:t>
             </a:r>
           </a:p>
         </p:txBody>
@@ -15546,8 +15546,8 @@
         </p:nvSpPr>
         <p:spPr>
           <a:xfrm>
-            <a:off x="3520440" y="3200400"/>
-            <a:ext cx="2560320" cy="566928"/>
+            <a:off x="3200400" y="3273552"/>
+            <a:ext cx="2560320" cy="594360"/>
           </a:xfrm>
           <a:prstGeom prst="rect">
             <a:avLst/>
@@ -15591,8 +15591,8 @@
         </p:nvSpPr>
         <p:spPr>
           <a:xfrm>
-            <a:off x="3547872" y="3236976"/>
-            <a:ext cx="2505456" cy="256032"/>
+            <a:off x="3246120" y="3310128"/>
+            <a:ext cx="2468879" cy="256032"/>
           </a:xfrm>
           <a:prstGeom prst="rect">
             <a:avLst/>
@@ -15625,28 +15625,28 @@
         </p:nvSpPr>
         <p:spPr>
           <a:xfrm>
-            <a:off x="3547872" y="3511296"/>
-            <a:ext cx="2505456" cy="201168"/>
-          </a:xfrm>
-          <a:prstGeom prst="rect">
-            <a:avLst/>
-          </a:prstGeom>
-          <a:noFill/>
-        </p:spPr>
-        <p:txBody>
-          <a:bodyPr wrap="square">
-            <a:spAutoFit/>
-          </a:bodyPr>
-          <a:lstStyle/>
-          <a:p>
-            <a:pPr algn="ctr"/>
-            <a:r>
-              <a:rPr sz="900" b="0">
+            <a:off x="3246120" y="3611880"/>
+            <a:ext cx="2468879" cy="182880"/>
+          </a:xfrm>
+          <a:prstGeom prst="rect">
+            <a:avLst/>
+          </a:prstGeom>
+          <a:noFill/>
+        </p:spPr>
+        <p:txBody>
+          <a:bodyPr wrap="square">
+            <a:spAutoFit/>
+          </a:bodyPr>
+          <a:lstStyle/>
+          <a:p>
+            <a:pPr algn="ctr"/>
+            <a:r>
+              <a:rPr sz="800" b="0">
                 <a:solidFill>
                   <a:srgbClr val="58A6FF"/>
                 </a:solidFill>
               </a:rPr>
-              <a:t>mcp_server.py  « query_repo »</a:t>
+              <a:t>mcp_server.py  ·  query_repo</a:t>
             </a:r>
           </a:p>
         </p:txBody>
@@ -15659,8 +15659,8 @@
         </p:nvSpPr>
         <p:spPr>
           <a:xfrm>
-            <a:off x="6675120" y="1920240"/>
-            <a:ext cx="2377440" cy="960120"/>
+            <a:off x="6492240" y="1828800"/>
+            <a:ext cx="2468880" cy="1005840"/>
           </a:xfrm>
           <a:prstGeom prst="rect">
             <a:avLst/>
@@ -15704,8 +15704,8 @@
         </p:nvSpPr>
         <p:spPr>
           <a:xfrm>
-            <a:off x="6711696" y="1984248"/>
-            <a:ext cx="2304288" cy="832104"/>
+            <a:off x="6537959" y="1920240"/>
+            <a:ext cx="2377440" cy="822960"/>
           </a:xfrm>
           <a:prstGeom prst="rect">
             <a:avLst/>
@@ -15727,7 +15727,7 @@
               </a:rPr>
               <a:t>RAG Engine
 repo_rag.py
-semantic + keyword search</a:t>
+hybrid: semantic + keyword</a:t>
             </a:r>
           </a:p>
         </p:txBody>
@@ -15740,8 +15740,89 @@
         </p:nvSpPr>
         <p:spPr>
           <a:xfrm>
-            <a:off x="6675120" y="3657600"/>
-            <a:ext cx="2377440" cy="640080"/>
+            <a:off x="9418320" y="1920240"/>
+            <a:ext cx="2560320" cy="914400"/>
+          </a:xfrm>
+          <a:prstGeom prst="rect">
+            <a:avLst/>
+          </a:prstGeom>
+          <a:solidFill>
+            <a:srgbClr val="101825"/>
+          </a:solidFill>
+          <a:ln w="9525">
+            <a:solidFill>
+              <a:srgbClr val="58A6FF"/>
+            </a:solidFill>
+          </a:ln>
+        </p:spPr>
+        <p:style>
+          <a:lnRef idx="1">
+            <a:schemeClr val="accent1"/>
+          </a:lnRef>
+          <a:fillRef idx="3">
+            <a:schemeClr val="accent1"/>
+          </a:fillRef>
+          <a:effectRef idx="2">
+            <a:schemeClr val="accent1"/>
+          </a:effectRef>
+          <a:fontRef idx="minor">
+            <a:schemeClr val="lt1"/>
+          </a:fontRef>
+        </p:style>
+        <p:txBody>
+          <a:bodyPr rtlCol="0" anchor="ctr"/>
+          <a:lstStyle/>
+          <a:p>
+            <a:pPr algn="ctr"/>
+          </a:p>
+        </p:txBody>
+      </p:sp>
+      <p:sp>
+        <p:nvSpPr>
+          <p:cNvPr id="20" name="TextBox 19"/>
+          <p:cNvSpPr txBox="1"/>
+          <p:nvPr/>
+        </p:nvSpPr>
+        <p:spPr>
+          <a:xfrm>
+            <a:off x="9464040" y="2011680"/>
+            <a:ext cx="2468879" cy="731520"/>
+          </a:xfrm>
+          <a:prstGeom prst="rect">
+            <a:avLst/>
+          </a:prstGeom>
+          <a:noFill/>
+        </p:spPr>
+        <p:txBody>
+          <a:bodyPr wrap="square">
+            <a:spAutoFit/>
+          </a:bodyPr>
+          <a:lstStyle/>
+          <a:p>
+            <a:pPr algn="ctr"/>
+            <a:r>
+              <a:rPr sz="1000" b="0">
+                <a:solidFill>
+                  <a:srgbClr val="F0F6FC"/>
+                </a:solidFill>
+              </a:rPr>
+              <a:t>Embedding Model
+all-MiniLM-L6-v2
+local  ·  offline  ·  ~90 MB</a:t>
+            </a:r>
+          </a:p>
+        </p:txBody>
+      </p:sp>
+      <p:sp>
+        <p:nvSpPr>
+          <p:cNvPr id="21" name="Rectangle 20"/>
+          <p:cNvSpPr/>
+          <p:nvPr/>
+        </p:nvSpPr>
+        <p:spPr>
+          <a:xfrm>
+            <a:off x="6492240" y="3703320"/>
+            <a:ext cx="2468880" cy="658368"/>
           </a:xfrm>
           <a:prstGeom prst="rect">
             <a:avLst/>
@@ -15779,14 +15860,14 @@
       </p:sp>
       <p:sp>
         <p:nvSpPr>
-          <p:cNvPr id="20" name="TextBox 19"/>
-          <p:cNvSpPr txBox="1"/>
-          <p:nvPr/>
-        </p:nvSpPr>
-        <p:spPr>
-          <a:xfrm>
-            <a:off x="6711696" y="3712463"/>
-            <a:ext cx="2304288" cy="530352"/>
+          <p:cNvPr id="22" name="TextBox 21"/>
+          <p:cNvSpPr txBox="1"/>
+          <p:nvPr/>
+        </p:nvSpPr>
+        <p:spPr>
+          <a:xfrm>
+            <a:off x="6537959" y="3776472"/>
+            <a:ext cx="2377440" cy="512063"/>
           </a:xfrm>
           <a:prstGeom prst="rect">
             <a:avLst/>
@@ -15806,22 +15887,22 @@
                   <a:srgbClr val="3FB950"/>
                 </a:solidFill>
               </a:rPr>
-              <a:t>ChromaDB  •  .chroma_db/
-vector store  (L2 distance)</a:t>
-            </a:r>
-          </a:p>
-        </p:txBody>
-      </p:sp>
-      <p:sp>
-        <p:nvSpPr>
-          <p:cNvPr id="21" name="Rectangle 20"/>
+              <a:t>ChromaDB  ·  .chroma_db/
+vector store  ·  L2 distance</a:t>
+            </a:r>
+          </a:p>
+        </p:txBody>
+      </p:sp>
+      <p:sp>
+        <p:nvSpPr>
+          <p:cNvPr id="23" name="Rectangle 22"/>
           <p:cNvSpPr/>
           <p:nvPr/>
         </p:nvSpPr>
         <p:spPr>
           <a:xfrm>
-            <a:off x="6263640" y="4892040"/>
-            <a:ext cx="1783080" cy="548640"/>
+            <a:off x="6080760" y="4709160"/>
+            <a:ext cx="1737360" cy="566928"/>
           </a:xfrm>
           <a:prstGeom prst="rect">
             <a:avLst/>
@@ -15859,14 +15940,14 @@
       </p:sp>
       <p:sp>
         <p:nvSpPr>
-          <p:cNvPr id="22" name="TextBox 21"/>
-          <p:cNvSpPr txBox="1"/>
-          <p:nvPr/>
-        </p:nvSpPr>
-        <p:spPr>
-          <a:xfrm>
-            <a:off x="6281928" y="4937760"/>
-            <a:ext cx="1746504" cy="457200"/>
+          <p:cNvPr id="24" name="TextBox 23"/>
+          <p:cNvSpPr txBox="1"/>
+          <p:nvPr/>
+        </p:nvSpPr>
+        <p:spPr>
+          <a:xfrm>
+            <a:off x="6108192" y="4764024"/>
+            <a:ext cx="1682495" cy="457200"/>
           </a:xfrm>
           <a:prstGeom prst="rect">
             <a:avLst/>
@@ -15894,14 +15975,14 @@
       </p:sp>
       <p:sp>
         <p:nvSpPr>
-          <p:cNvPr id="23" name="Rectangle 22"/>
+          <p:cNvPr id="25" name="Rectangle 24"/>
           <p:cNvSpPr/>
           <p:nvPr/>
         </p:nvSpPr>
         <p:spPr>
           <a:xfrm>
-            <a:off x="8275320" y="4892040"/>
-            <a:ext cx="1783080" cy="548640"/>
+            <a:off x="8092440" y="4709160"/>
+            <a:ext cx="1737360" cy="566928"/>
           </a:xfrm>
           <a:prstGeom prst="rect">
             <a:avLst/>
@@ -15939,14 +16020,14 @@
       </p:sp>
       <p:sp>
         <p:nvSpPr>
-          <p:cNvPr id="24" name="TextBox 23"/>
-          <p:cNvSpPr txBox="1"/>
-          <p:nvPr/>
-        </p:nvSpPr>
-        <p:spPr>
-          <a:xfrm>
-            <a:off x="8293608" y="4937760"/>
-            <a:ext cx="1746504" cy="457200"/>
+          <p:cNvPr id="26" name="TextBox 25"/>
+          <p:cNvSpPr txBox="1"/>
+          <p:nvPr/>
+        </p:nvSpPr>
+        <p:spPr>
+          <a:xfrm>
+            <a:off x="8119871" y="4764024"/>
+            <a:ext cx="1682495" cy="457200"/>
           </a:xfrm>
           <a:prstGeom prst="rect">
             <a:avLst/>
@@ -15972,18 +16053,136 @@
           </a:p>
         </p:txBody>
       </p:sp>
+      <p:sp>
+        <p:nvSpPr>
+          <p:cNvPr id="27" name="Rectangle 26"/>
+          <p:cNvSpPr/>
+          <p:nvPr/>
+        </p:nvSpPr>
+        <p:spPr>
+          <a:xfrm>
+            <a:off x="9418320" y="3611880"/>
+            <a:ext cx="2560320" cy="1463040"/>
+          </a:xfrm>
+          <a:prstGeom prst="rect">
+            <a:avLst/>
+          </a:prstGeom>
+          <a:solidFill>
+            <a:srgbClr val="180707"/>
+          </a:solidFill>
+          <a:ln w="9525">
+            <a:solidFill>
+              <a:srgbClr val="FF7B72"/>
+            </a:solidFill>
+          </a:ln>
+        </p:spPr>
+        <p:style>
+          <a:lnRef idx="1">
+            <a:schemeClr val="accent1"/>
+          </a:lnRef>
+          <a:fillRef idx="3">
+            <a:schemeClr val="accent1"/>
+          </a:fillRef>
+          <a:effectRef idx="2">
+            <a:schemeClr val="accent1"/>
+          </a:effectRef>
+          <a:fontRef idx="minor">
+            <a:schemeClr val="lt1"/>
+          </a:fontRef>
+        </p:style>
+        <p:txBody>
+          <a:bodyPr rtlCol="0" anchor="ctr"/>
+          <a:lstStyle/>
+          <a:p>
+            <a:pPr algn="ctr"/>
+          </a:p>
+        </p:txBody>
+      </p:sp>
+      <p:sp>
+        <p:nvSpPr>
+          <p:cNvPr id="28" name="TextBox 27"/>
+          <p:cNvSpPr txBox="1"/>
+          <p:nvPr/>
+        </p:nvSpPr>
+        <p:spPr>
+          <a:xfrm>
+            <a:off x="9491472" y="3685032"/>
+            <a:ext cx="2414015" cy="228600"/>
+          </a:xfrm>
+          <a:prstGeom prst="rect">
+            <a:avLst/>
+          </a:prstGeom>
+          <a:noFill/>
+        </p:spPr>
+        <p:txBody>
+          <a:bodyPr wrap="square">
+            <a:spAutoFit/>
+          </a:bodyPr>
+          <a:lstStyle/>
+          <a:p>
+            <a:pPr algn="l"/>
+            <a:r>
+              <a:rPr sz="900" b="1">
+                <a:solidFill>
+                  <a:srgbClr val="FF7B72"/>
+                </a:solidFill>
+              </a:rPr>
+              <a:t>⚡  Normally: LLM API calls</a:t>
+            </a:r>
+          </a:p>
+        </p:txBody>
+      </p:sp>
+      <p:sp>
+        <p:nvSpPr>
+          <p:cNvPr id="29" name="TextBox 28"/>
+          <p:cNvSpPr txBox="1"/>
+          <p:nvPr/>
+        </p:nvSpPr>
+        <p:spPr>
+          <a:xfrm>
+            <a:off x="9491472" y="3959352"/>
+            <a:ext cx="2414015" cy="1005840"/>
+          </a:xfrm>
+          <a:prstGeom prst="rect">
+            <a:avLst/>
+          </a:prstGeom>
+          <a:noFill/>
+        </p:spPr>
+        <p:txBody>
+          <a:bodyPr wrap="square">
+            <a:spAutoFit/>
+          </a:bodyPr>
+          <a:lstStyle/>
+          <a:p>
+            <a:pPr algn="l"/>
+            <a:r>
+              <a:rPr sz="800" b="0">
+                <a:solidFill>
+                  <a:srgbClr val="FF7B72"/>
+                </a:solidFill>
+              </a:rPr>
+              <a:t>✗  Embedding API  (text-embedding-ada-002)
+   → replaced by all-MiniLM-L6-v2
+      runs locally, no API key, no cloud
+✗  Answer generation  (GPT-4 / Claude API)
+   → not needed: Copilot IS the LLM
+      receives chunks, synthesises answer</a:t>
+            </a:r>
+          </a:p>
+        </p:txBody>
+      </p:sp>
       <p:cxnSp>
         <p:nvCxnSpPr>
-          <p:cNvPr id="25" name="Connector 24"/>
+          <p:cNvPr id="30" name="Connector 29"/>
           <p:cNvCxnSpPr/>
           <p:nvPr/>
         </p:nvCxnSpPr>
         <p:spPr>
           <a:xfrm flipH="1">
-            <a:off x="1572768" y="1344168"/>
-            <a:ext cx="3364992" cy="621792"/>
-          </a:xfrm>
-          <a:prstGeom prst="line">
+            <a:off x="1508760" y="1325880"/>
+            <a:ext cx="3337560" cy="640080"/>
+          </a:xfrm>
+          <a:prstGeom prst="bentConnector3">
             <a:avLst/>
           </a:prstGeom>
           <a:ln w="15876">
@@ -16010,50 +16209,95 @@
       </p:cxnSp>
       <p:sp>
         <p:nvSpPr>
-          <p:cNvPr id="26" name="TextBox 25"/>
-          <p:cNvSpPr txBox="1"/>
-          <p:nvPr/>
-        </p:nvSpPr>
-        <p:spPr>
-          <a:xfrm>
-            <a:off x="2432304" y="1499616"/>
-            <a:ext cx="1645920" cy="292608"/>
-          </a:xfrm>
-          <a:prstGeom prst="rect">
-            <a:avLst/>
-          </a:prstGeom>
-          <a:noFill/>
-        </p:spPr>
-        <p:txBody>
-          <a:bodyPr wrap="square">
-            <a:spAutoFit/>
-          </a:bodyPr>
-          <a:lstStyle/>
-          <a:p>
-            <a:pPr algn="ctr"/>
-            <a:r>
-              <a:rPr sz="800" b="0">
-                <a:solidFill>
-                  <a:srgbClr val="BC8CFF"/>
-                </a:solidFill>
-              </a:rPr>
-              <a:t>get_relevant_repos</a:t>
+          <p:cNvPr id="31" name="Rectangle 30"/>
+          <p:cNvSpPr/>
+          <p:nvPr/>
+        </p:nvSpPr>
+        <p:spPr>
+          <a:xfrm>
+            <a:off x="3049523" y="1517903"/>
+            <a:ext cx="256032" cy="256032"/>
+          </a:xfrm>
+          <a:prstGeom prst="rect">
+            <a:avLst/>
+          </a:prstGeom>
+          <a:solidFill>
+            <a:srgbClr val="BC8CFF"/>
+          </a:solidFill>
+          <a:ln w="9525">
+            <a:solidFill>
+              <a:srgbClr val="BC8CFF"/>
+            </a:solidFill>
+          </a:ln>
+        </p:spPr>
+        <p:style>
+          <a:lnRef idx="1">
+            <a:schemeClr val="accent1"/>
+          </a:lnRef>
+          <a:fillRef idx="3">
+            <a:schemeClr val="accent1"/>
+          </a:fillRef>
+          <a:effectRef idx="2">
+            <a:schemeClr val="accent1"/>
+          </a:effectRef>
+          <a:fontRef idx="minor">
+            <a:schemeClr val="lt1"/>
+          </a:fontRef>
+        </p:style>
+        <p:txBody>
+          <a:bodyPr rtlCol="0" anchor="ctr"/>
+          <a:lstStyle/>
+          <a:p>
+            <a:pPr algn="ctr"/>
+          </a:p>
+        </p:txBody>
+      </p:sp>
+      <p:sp>
+        <p:nvSpPr>
+          <p:cNvPr id="32" name="TextBox 31"/>
+          <p:cNvSpPr txBox="1"/>
+          <p:nvPr/>
+        </p:nvSpPr>
+        <p:spPr>
+          <a:xfrm>
+            <a:off x="3049523" y="1499616"/>
+            <a:ext cx="256032" cy="256032"/>
+          </a:xfrm>
+          <a:prstGeom prst="rect">
+            <a:avLst/>
+          </a:prstGeom>
+          <a:noFill/>
+        </p:spPr>
+        <p:txBody>
+          <a:bodyPr wrap="square">
+            <a:spAutoFit/>
+          </a:bodyPr>
+          <a:lstStyle/>
+          <a:p>
+            <a:pPr algn="ctr"/>
+            <a:r>
+              <a:rPr sz="800" b="1">
+                <a:solidFill>
+                  <a:srgbClr val="0D1117"/>
+                </a:solidFill>
+              </a:rPr>
+              <a:t>1</a:t>
             </a:r>
           </a:p>
         </p:txBody>
       </p:sp>
       <p:cxnSp>
         <p:nvCxnSpPr>
-          <p:cNvPr id="27" name="Connector 26"/>
+          <p:cNvPr id="33" name="Connector 32"/>
           <p:cNvCxnSpPr/>
           <p:nvPr/>
         </p:nvCxnSpPr>
         <p:spPr>
           <a:xfrm flipH="1">
-            <a:off x="4800600" y="1344168"/>
-            <a:ext cx="1371600" cy="27432"/>
-          </a:xfrm>
-          <a:prstGeom prst="line">
+            <a:off x="4480560" y="1325880"/>
+            <a:ext cx="1645919" cy="64008"/>
+          </a:xfrm>
+          <a:prstGeom prst="bentConnector3">
             <a:avLst/>
           </a:prstGeom>
           <a:ln w="15876">
@@ -16080,50 +16324,129 @@
       </p:cxnSp>
       <p:sp>
         <p:nvSpPr>
-          <p:cNvPr id="28" name="TextBox 27"/>
-          <p:cNvSpPr txBox="1"/>
-          <p:nvPr/>
-        </p:nvSpPr>
-        <p:spPr>
-          <a:xfrm>
-            <a:off x="4663440" y="1202436"/>
-            <a:ext cx="1645920" cy="292608"/>
-          </a:xfrm>
-          <a:prstGeom prst="rect">
-            <a:avLst/>
-          </a:prstGeom>
-          <a:noFill/>
-        </p:spPr>
-        <p:txBody>
-          <a:bodyPr wrap="square">
-            <a:spAutoFit/>
-          </a:bodyPr>
-          <a:lstStyle/>
-          <a:p>
-            <a:pPr algn="ctr"/>
-            <a:r>
-              <a:rPr sz="800" b="0">
+          <p:cNvPr id="34" name="Rectangle 33"/>
+          <p:cNvSpPr/>
+          <p:nvPr/>
+        </p:nvSpPr>
+        <p:spPr>
+          <a:xfrm>
+            <a:off x="5175504" y="1229867"/>
+            <a:ext cx="256032" cy="256032"/>
+          </a:xfrm>
+          <a:prstGeom prst="rect">
+            <a:avLst/>
+          </a:prstGeom>
+          <a:solidFill>
+            <a:srgbClr val="58A6FF"/>
+          </a:solidFill>
+          <a:ln w="9525">
+            <a:solidFill>
+              <a:srgbClr val="58A6FF"/>
+            </a:solidFill>
+          </a:ln>
+        </p:spPr>
+        <p:style>
+          <a:lnRef idx="1">
+            <a:schemeClr val="accent1"/>
+          </a:lnRef>
+          <a:fillRef idx="3">
+            <a:schemeClr val="accent1"/>
+          </a:fillRef>
+          <a:effectRef idx="2">
+            <a:schemeClr val="accent1"/>
+          </a:effectRef>
+          <a:fontRef idx="minor">
+            <a:schemeClr val="lt1"/>
+          </a:fontRef>
+        </p:style>
+        <p:txBody>
+          <a:bodyPr rtlCol="0" anchor="ctr"/>
+          <a:lstStyle/>
+          <a:p>
+            <a:pPr algn="ctr"/>
+          </a:p>
+        </p:txBody>
+      </p:sp>
+      <p:sp>
+        <p:nvSpPr>
+          <p:cNvPr id="35" name="TextBox 34"/>
+          <p:cNvSpPr txBox="1"/>
+          <p:nvPr/>
+        </p:nvSpPr>
+        <p:spPr>
+          <a:xfrm>
+            <a:off x="5175504" y="1211580"/>
+            <a:ext cx="256032" cy="256032"/>
+          </a:xfrm>
+          <a:prstGeom prst="rect">
+            <a:avLst/>
+          </a:prstGeom>
+          <a:noFill/>
+        </p:spPr>
+        <p:txBody>
+          <a:bodyPr wrap="square">
+            <a:spAutoFit/>
+          </a:bodyPr>
+          <a:lstStyle/>
+          <a:p>
+            <a:pPr algn="ctr"/>
+            <a:r>
+              <a:rPr sz="800" b="1">
+                <a:solidFill>
+                  <a:srgbClr val="0D1117"/>
+                </a:solidFill>
+              </a:rPr>
+              <a:t>2</a:t>
+            </a:r>
+          </a:p>
+        </p:txBody>
+      </p:sp>
+      <p:sp>
+        <p:nvSpPr>
+          <p:cNvPr id="36" name="TextBox 35"/>
+          <p:cNvSpPr txBox="1"/>
+          <p:nvPr/>
+        </p:nvSpPr>
+        <p:spPr>
+          <a:xfrm>
+            <a:off x="5413248" y="1266443"/>
+            <a:ext cx="320040" cy="201168"/>
+          </a:xfrm>
+          <a:prstGeom prst="rect">
+            <a:avLst/>
+          </a:prstGeom>
+          <a:noFill/>
+        </p:spPr>
+        <p:txBody>
+          <a:bodyPr wrap="square">
+            <a:spAutoFit/>
+          </a:bodyPr>
+          <a:lstStyle/>
+          <a:p>
+            <a:pPr algn="l"/>
+            <a:r>
+              <a:rPr sz="800" b="1">
                 <a:solidFill>
                   <a:srgbClr val="58A6FF"/>
                 </a:solidFill>
               </a:rPr>
-              <a:t>query_repo (×3)</a:t>
+              <a:t>×3</a:t>
             </a:r>
           </a:p>
         </p:txBody>
       </p:sp>
       <p:cxnSp>
         <p:nvCxnSpPr>
-          <p:cNvPr id="29" name="Connector 28"/>
+          <p:cNvPr id="37" name="Connector 36"/>
           <p:cNvCxnSpPr/>
           <p:nvPr/>
         </p:nvCxnSpPr>
         <p:spPr>
           <a:xfrm flipV="1">
-            <a:off x="2880360" y="1655064"/>
-            <a:ext cx="640080" cy="649224"/>
-          </a:xfrm>
-          <a:prstGeom prst="line">
+            <a:off x="2834640" y="1687068"/>
+            <a:ext cx="365760" cy="690372"/>
+          </a:xfrm>
+          <a:prstGeom prst="bentConnector3">
             <a:avLst/>
           </a:prstGeom>
           <a:ln w="15876">
@@ -16150,305 +16473,21 @@
       </p:cxnSp>
       <p:cxnSp>
         <p:nvCxnSpPr>
-          <p:cNvPr id="30" name="Connector 29"/>
+          <p:cNvPr id="38" name="Connector 37"/>
           <p:cNvCxnSpPr/>
           <p:nvPr/>
         </p:nvCxnSpPr>
         <p:spPr>
           <a:xfrm>
-            <a:off x="2880360" y="2377440"/>
-            <a:ext cx="640080" cy="192024"/>
-          </a:xfrm>
-          <a:prstGeom prst="line">
+            <a:off x="2834640" y="2377440"/>
+            <a:ext cx="365760" cy="251460"/>
+          </a:xfrm>
+          <a:prstGeom prst="bentConnector3">
             <a:avLst/>
           </a:prstGeom>
           <a:ln w="15876">
             <a:solidFill>
               <a:srgbClr val="3FB950"/>
-            </a:solidFill>
-            <a:tailEnd type="arrow" w="med" len="med"/>
-          </a:ln>
-        </p:spPr>
-        <p:style>
-          <a:lnRef idx="2">
-            <a:schemeClr val="accent1"/>
-          </a:lnRef>
-          <a:fillRef idx="0">
-            <a:schemeClr val="accent1"/>
-          </a:fillRef>
-          <a:effectRef idx="1">
-            <a:schemeClr val="accent1"/>
-          </a:effectRef>
-          <a:fontRef idx="minor">
-            <a:schemeClr val="tx1"/>
-          </a:fontRef>
-        </p:style>
-      </p:cxnSp>
-      <p:cxnSp>
-        <p:nvCxnSpPr>
-          <p:cNvPr id="31" name="Connector 30"/>
-          <p:cNvCxnSpPr/>
-          <p:nvPr/>
-        </p:nvCxnSpPr>
-        <p:spPr>
-          <a:xfrm>
-            <a:off x="2880360" y="2450592"/>
-            <a:ext cx="640080" cy="1033272"/>
-          </a:xfrm>
-          <a:prstGeom prst="line">
-            <a:avLst/>
-          </a:prstGeom>
-          <a:ln w="15876">
-            <a:solidFill>
-              <a:srgbClr val="3FB950"/>
-            </a:solidFill>
-            <a:tailEnd type="arrow" w="med" len="med"/>
-          </a:ln>
-        </p:spPr>
-        <p:style>
-          <a:lnRef idx="2">
-            <a:schemeClr val="accent1"/>
-          </a:lnRef>
-          <a:fillRef idx="0">
-            <a:schemeClr val="accent1"/>
-          </a:fillRef>
-          <a:effectRef idx="1">
-            <a:schemeClr val="accent1"/>
-          </a:effectRef>
-          <a:fontRef idx="minor">
-            <a:schemeClr val="tx1"/>
-          </a:fontRef>
-        </p:style>
-      </p:cxnSp>
-      <p:cxnSp>
-        <p:nvCxnSpPr>
-          <p:cNvPr id="32" name="Connector 31"/>
-          <p:cNvCxnSpPr/>
-          <p:nvPr/>
-        </p:nvCxnSpPr>
-        <p:spPr>
-          <a:xfrm>
-            <a:off x="6080760" y="1655064"/>
-            <a:ext cx="594360" cy="521208"/>
-          </a:xfrm>
-          <a:prstGeom prst="line">
-            <a:avLst/>
-          </a:prstGeom>
-          <a:ln w="15876">
-            <a:solidFill>
-              <a:srgbClr val="58A6FF"/>
-            </a:solidFill>
-            <a:tailEnd type="arrow" w="med" len="med"/>
-          </a:ln>
-        </p:spPr>
-        <p:style>
-          <a:lnRef idx="2">
-            <a:schemeClr val="accent1"/>
-          </a:lnRef>
-          <a:fillRef idx="0">
-            <a:schemeClr val="accent1"/>
-          </a:fillRef>
-          <a:effectRef idx="1">
-            <a:schemeClr val="accent1"/>
-          </a:effectRef>
-          <a:fontRef idx="minor">
-            <a:schemeClr val="tx1"/>
-          </a:fontRef>
-        </p:style>
-      </p:cxnSp>
-      <p:cxnSp>
-        <p:nvCxnSpPr>
-          <p:cNvPr id="33" name="Connector 32"/>
-          <p:cNvCxnSpPr/>
-          <p:nvPr/>
-        </p:nvCxnSpPr>
-        <p:spPr>
-          <a:xfrm flipV="1">
-            <a:off x="6080760" y="2395728"/>
-            <a:ext cx="594360" cy="173736"/>
-          </a:xfrm>
-          <a:prstGeom prst="line">
-            <a:avLst/>
-          </a:prstGeom>
-          <a:ln w="15876">
-            <a:solidFill>
-              <a:srgbClr val="58A6FF"/>
-            </a:solidFill>
-            <a:tailEnd type="arrow" w="med" len="med"/>
-          </a:ln>
-        </p:spPr>
-        <p:style>
-          <a:lnRef idx="2">
-            <a:schemeClr val="accent1"/>
-          </a:lnRef>
-          <a:fillRef idx="0">
-            <a:schemeClr val="accent1"/>
-          </a:fillRef>
-          <a:effectRef idx="1">
-            <a:schemeClr val="accent1"/>
-          </a:effectRef>
-          <a:fontRef idx="minor">
-            <a:schemeClr val="tx1"/>
-          </a:fontRef>
-        </p:style>
-      </p:cxnSp>
-      <p:cxnSp>
-        <p:nvCxnSpPr>
-          <p:cNvPr id="34" name="Connector 33"/>
-          <p:cNvCxnSpPr/>
-          <p:nvPr/>
-        </p:nvCxnSpPr>
-        <p:spPr>
-          <a:xfrm flipV="1">
-            <a:off x="6080760" y="2624328"/>
-            <a:ext cx="594360" cy="859536"/>
-          </a:xfrm>
-          <a:prstGeom prst="line">
-            <a:avLst/>
-          </a:prstGeom>
-          <a:ln w="15876">
-            <a:solidFill>
-              <a:srgbClr val="58A6FF"/>
-            </a:solidFill>
-            <a:tailEnd type="arrow" w="med" len="med"/>
-          </a:ln>
-        </p:spPr>
-        <p:style>
-          <a:lnRef idx="2">
-            <a:schemeClr val="accent1"/>
-          </a:lnRef>
-          <a:fillRef idx="0">
-            <a:schemeClr val="accent1"/>
-          </a:fillRef>
-          <a:effectRef idx="1">
-            <a:schemeClr val="accent1"/>
-          </a:effectRef>
-          <a:fontRef idx="minor">
-            <a:schemeClr val="tx1"/>
-          </a:fontRef>
-        </p:style>
-      </p:cxnSp>
-      <p:sp>
-        <p:nvSpPr>
-          <p:cNvPr id="35" name="TextBox 34"/>
-          <p:cNvSpPr txBox="1"/>
-          <p:nvPr/>
-        </p:nvSpPr>
-        <p:spPr>
-          <a:xfrm>
-            <a:off x="5554979" y="2327148"/>
-            <a:ext cx="1645920" cy="292608"/>
-          </a:xfrm>
-          <a:prstGeom prst="rect">
-            <a:avLst/>
-          </a:prstGeom>
-          <a:noFill/>
-        </p:spPr>
-        <p:txBody>
-          <a:bodyPr wrap="square">
-            <a:spAutoFit/>
-          </a:bodyPr>
-          <a:lstStyle/>
-          <a:p>
-            <a:pPr algn="ctr"/>
-            <a:r>
-              <a:rPr sz="800" b="0">
-                <a:solidFill>
-                  <a:srgbClr val="58A6FF"/>
-                </a:solidFill>
-              </a:rPr>
-              <a:t>query()</a:t>
-            </a:r>
-          </a:p>
-        </p:txBody>
-      </p:sp>
-      <p:cxnSp>
-        <p:nvCxnSpPr>
-          <p:cNvPr id="36" name="Connector 35"/>
-          <p:cNvCxnSpPr/>
-          <p:nvPr/>
-        </p:nvCxnSpPr>
-        <p:spPr>
-          <a:xfrm>
-            <a:off x="7863840" y="2880360"/>
-            <a:ext cx="0" cy="777240"/>
-          </a:xfrm>
-          <a:prstGeom prst="line">
-            <a:avLst/>
-          </a:prstGeom>
-          <a:ln w="15876">
-            <a:solidFill>
-              <a:srgbClr val="F0883E"/>
-            </a:solidFill>
-            <a:tailEnd type="arrow" w="med" len="med"/>
-          </a:ln>
-        </p:spPr>
-        <p:style>
-          <a:lnRef idx="2">
-            <a:schemeClr val="accent1"/>
-          </a:lnRef>
-          <a:fillRef idx="0">
-            <a:schemeClr val="accent1"/>
-          </a:fillRef>
-          <a:effectRef idx="1">
-            <a:schemeClr val="accent1"/>
-          </a:effectRef>
-          <a:fontRef idx="minor">
-            <a:schemeClr val="tx1"/>
-          </a:fontRef>
-        </p:style>
-      </p:cxnSp>
-      <p:sp>
-        <p:nvSpPr>
-          <p:cNvPr id="37" name="TextBox 36"/>
-          <p:cNvSpPr txBox="1"/>
-          <p:nvPr/>
-        </p:nvSpPr>
-        <p:spPr>
-          <a:xfrm>
-            <a:off x="7040879" y="3113532"/>
-            <a:ext cx="1645920" cy="292608"/>
-          </a:xfrm>
-          <a:prstGeom prst="rect">
-            <a:avLst/>
-          </a:prstGeom>
-          <a:noFill/>
-        </p:spPr>
-        <p:txBody>
-          <a:bodyPr wrap="square">
-            <a:spAutoFit/>
-          </a:bodyPr>
-          <a:lstStyle/>
-          <a:p>
-            <a:pPr algn="ctr"/>
-            <a:r>
-              <a:rPr sz="800" b="0">
-                <a:solidFill>
-                  <a:srgbClr val="F0883E"/>
-                </a:solidFill>
-              </a:rPr>
-              <a:t>vector search</a:t>
-            </a:r>
-          </a:p>
-        </p:txBody>
-      </p:sp>
-      <p:cxnSp>
-        <p:nvCxnSpPr>
-          <p:cNvPr id="38" name="Connector 37"/>
-          <p:cNvCxnSpPr/>
-          <p:nvPr/>
-        </p:nvCxnSpPr>
-        <p:spPr>
-          <a:xfrm flipH="1">
-            <a:off x="7150608" y="4297680"/>
-            <a:ext cx="118872" cy="594360"/>
-          </a:xfrm>
-          <a:prstGeom prst="line">
-            <a:avLst/>
-          </a:prstGeom>
-          <a:ln w="15876">
-            <a:solidFill>
-              <a:srgbClr val="8B949E"/>
             </a:solidFill>
             <a:tailEnd type="arrow" w="med" len="med"/>
           </a:ln>
@@ -16476,10 +16515,542 @@
         </p:nvCxnSpPr>
         <p:spPr>
           <a:xfrm>
-            <a:off x="8458200" y="4297680"/>
-            <a:ext cx="749808" cy="594360"/>
-          </a:xfrm>
-          <a:prstGeom prst="line">
+            <a:off x="2834640" y="2377440"/>
+            <a:ext cx="365760" cy="1193292"/>
+          </a:xfrm>
+          <a:prstGeom prst="bentConnector3">
+            <a:avLst/>
+          </a:prstGeom>
+          <a:ln w="15876">
+            <a:solidFill>
+              <a:srgbClr val="3FB950"/>
+            </a:solidFill>
+            <a:tailEnd type="arrow" w="med" len="med"/>
+          </a:ln>
+        </p:spPr>
+        <p:style>
+          <a:lnRef idx="2">
+            <a:schemeClr val="accent1"/>
+          </a:lnRef>
+          <a:fillRef idx="0">
+            <a:schemeClr val="accent1"/>
+          </a:fillRef>
+          <a:effectRef idx="1">
+            <a:schemeClr val="accent1"/>
+          </a:effectRef>
+          <a:fontRef idx="minor">
+            <a:schemeClr val="tx1"/>
+          </a:fontRef>
+        </p:style>
+      </p:cxnSp>
+      <p:sp>
+        <p:nvSpPr>
+          <p:cNvPr id="40" name="Rectangle 39"/>
+          <p:cNvSpPr/>
+          <p:nvPr/>
+        </p:nvSpPr>
+        <p:spPr>
+          <a:xfrm>
+            <a:off x="2889503" y="2375153"/>
+            <a:ext cx="256032" cy="256032"/>
+          </a:xfrm>
+          <a:prstGeom prst="rect">
+            <a:avLst/>
+          </a:prstGeom>
+          <a:solidFill>
+            <a:srgbClr val="3FB950"/>
+          </a:solidFill>
+          <a:ln w="9525">
+            <a:solidFill>
+              <a:srgbClr val="3FB950"/>
+            </a:solidFill>
+          </a:ln>
+        </p:spPr>
+        <p:style>
+          <a:lnRef idx="1">
+            <a:schemeClr val="accent1"/>
+          </a:lnRef>
+          <a:fillRef idx="3">
+            <a:schemeClr val="accent1"/>
+          </a:fillRef>
+          <a:effectRef idx="2">
+            <a:schemeClr val="accent1"/>
+          </a:effectRef>
+          <a:fontRef idx="minor">
+            <a:schemeClr val="lt1"/>
+          </a:fontRef>
+        </p:style>
+        <p:txBody>
+          <a:bodyPr rtlCol="0" anchor="ctr"/>
+          <a:lstStyle/>
+          <a:p>
+            <a:pPr algn="ctr"/>
+          </a:p>
+        </p:txBody>
+      </p:sp>
+      <p:sp>
+        <p:nvSpPr>
+          <p:cNvPr id="41" name="TextBox 40"/>
+          <p:cNvSpPr txBox="1"/>
+          <p:nvPr/>
+        </p:nvSpPr>
+        <p:spPr>
+          <a:xfrm>
+            <a:off x="2889503" y="2356865"/>
+            <a:ext cx="256032" cy="256032"/>
+          </a:xfrm>
+          <a:prstGeom prst="rect">
+            <a:avLst/>
+          </a:prstGeom>
+          <a:noFill/>
+        </p:spPr>
+        <p:txBody>
+          <a:bodyPr wrap="square">
+            <a:spAutoFit/>
+          </a:bodyPr>
+          <a:lstStyle/>
+          <a:p>
+            <a:pPr algn="ctr"/>
+            <a:r>
+              <a:rPr sz="800" b="1">
+                <a:solidFill>
+                  <a:srgbClr val="0D1117"/>
+                </a:solidFill>
+              </a:rPr>
+              <a:t>3</a:t>
+            </a:r>
+          </a:p>
+        </p:txBody>
+      </p:sp>
+      <p:cxnSp>
+        <p:nvCxnSpPr>
+          <p:cNvPr id="42" name="Connector 41"/>
+          <p:cNvCxnSpPr/>
+          <p:nvPr/>
+        </p:nvCxnSpPr>
+        <p:spPr>
+          <a:xfrm>
+            <a:off x="5760720" y="1687068"/>
+            <a:ext cx="731520" cy="644652"/>
+          </a:xfrm>
+          <a:prstGeom prst="bentConnector3">
+            <a:avLst/>
+          </a:prstGeom>
+          <a:ln w="15876">
+            <a:solidFill>
+              <a:srgbClr val="58A6FF"/>
+            </a:solidFill>
+            <a:tailEnd type="arrow" w="med" len="med"/>
+          </a:ln>
+        </p:spPr>
+        <p:style>
+          <a:lnRef idx="2">
+            <a:schemeClr val="accent1"/>
+          </a:lnRef>
+          <a:fillRef idx="0">
+            <a:schemeClr val="accent1"/>
+          </a:fillRef>
+          <a:effectRef idx="1">
+            <a:schemeClr val="accent1"/>
+          </a:effectRef>
+          <a:fontRef idx="minor">
+            <a:schemeClr val="tx1"/>
+          </a:fontRef>
+        </p:style>
+      </p:cxnSp>
+      <p:cxnSp>
+        <p:nvCxnSpPr>
+          <p:cNvPr id="43" name="Connector 42"/>
+          <p:cNvCxnSpPr/>
+          <p:nvPr/>
+        </p:nvCxnSpPr>
+        <p:spPr>
+          <a:xfrm flipV="1">
+            <a:off x="5760720" y="2331720"/>
+            <a:ext cx="731520" cy="297180"/>
+          </a:xfrm>
+          <a:prstGeom prst="bentConnector3">
+            <a:avLst/>
+          </a:prstGeom>
+          <a:ln w="15876">
+            <a:solidFill>
+              <a:srgbClr val="58A6FF"/>
+            </a:solidFill>
+            <a:tailEnd type="arrow" w="med" len="med"/>
+          </a:ln>
+        </p:spPr>
+        <p:style>
+          <a:lnRef idx="2">
+            <a:schemeClr val="accent1"/>
+          </a:lnRef>
+          <a:fillRef idx="0">
+            <a:schemeClr val="accent1"/>
+          </a:fillRef>
+          <a:effectRef idx="1">
+            <a:schemeClr val="accent1"/>
+          </a:effectRef>
+          <a:fontRef idx="minor">
+            <a:schemeClr val="tx1"/>
+          </a:fontRef>
+        </p:style>
+      </p:cxnSp>
+      <p:cxnSp>
+        <p:nvCxnSpPr>
+          <p:cNvPr id="44" name="Connector 43"/>
+          <p:cNvCxnSpPr/>
+          <p:nvPr/>
+        </p:nvCxnSpPr>
+        <p:spPr>
+          <a:xfrm flipV="1">
+            <a:off x="5760720" y="2331720"/>
+            <a:ext cx="731520" cy="1239012"/>
+          </a:xfrm>
+          <a:prstGeom prst="bentConnector3">
+            <a:avLst/>
+          </a:prstGeom>
+          <a:ln w="15876">
+            <a:solidFill>
+              <a:srgbClr val="58A6FF"/>
+            </a:solidFill>
+            <a:tailEnd type="arrow" w="med" len="med"/>
+          </a:ln>
+        </p:spPr>
+        <p:style>
+          <a:lnRef idx="2">
+            <a:schemeClr val="accent1"/>
+          </a:lnRef>
+          <a:fillRef idx="0">
+            <a:schemeClr val="accent1"/>
+          </a:fillRef>
+          <a:effectRef idx="1">
+            <a:schemeClr val="accent1"/>
+          </a:effectRef>
+          <a:fontRef idx="minor">
+            <a:schemeClr val="tx1"/>
+          </a:fontRef>
+        </p:style>
+      </p:cxnSp>
+      <p:sp>
+        <p:nvSpPr>
+          <p:cNvPr id="45" name="Rectangle 44"/>
+          <p:cNvSpPr/>
+          <p:nvPr/>
+        </p:nvSpPr>
+        <p:spPr>
+          <a:xfrm>
+            <a:off x="5998464" y="2352294"/>
+            <a:ext cx="256032" cy="256032"/>
+          </a:xfrm>
+          <a:prstGeom prst="rect">
+            <a:avLst/>
+          </a:prstGeom>
+          <a:solidFill>
+            <a:srgbClr val="58A6FF"/>
+          </a:solidFill>
+          <a:ln w="9525">
+            <a:solidFill>
+              <a:srgbClr val="58A6FF"/>
+            </a:solidFill>
+          </a:ln>
+        </p:spPr>
+        <p:style>
+          <a:lnRef idx="1">
+            <a:schemeClr val="accent1"/>
+          </a:lnRef>
+          <a:fillRef idx="3">
+            <a:schemeClr val="accent1"/>
+          </a:fillRef>
+          <a:effectRef idx="2">
+            <a:schemeClr val="accent1"/>
+          </a:effectRef>
+          <a:fontRef idx="minor">
+            <a:schemeClr val="lt1"/>
+          </a:fontRef>
+        </p:style>
+        <p:txBody>
+          <a:bodyPr rtlCol="0" anchor="ctr"/>
+          <a:lstStyle/>
+          <a:p>
+            <a:pPr algn="ctr"/>
+          </a:p>
+        </p:txBody>
+      </p:sp>
+      <p:sp>
+        <p:nvSpPr>
+          <p:cNvPr id="46" name="TextBox 45"/>
+          <p:cNvSpPr txBox="1"/>
+          <p:nvPr/>
+        </p:nvSpPr>
+        <p:spPr>
+          <a:xfrm>
+            <a:off x="5998464" y="2334006"/>
+            <a:ext cx="256032" cy="256032"/>
+          </a:xfrm>
+          <a:prstGeom prst="rect">
+            <a:avLst/>
+          </a:prstGeom>
+          <a:noFill/>
+        </p:spPr>
+        <p:txBody>
+          <a:bodyPr wrap="square">
+            <a:spAutoFit/>
+          </a:bodyPr>
+          <a:lstStyle/>
+          <a:p>
+            <a:pPr algn="ctr"/>
+            <a:r>
+              <a:rPr sz="800" b="1">
+                <a:solidFill>
+                  <a:srgbClr val="0D1117"/>
+                </a:solidFill>
+              </a:rPr>
+              <a:t>4</a:t>
+            </a:r>
+          </a:p>
+        </p:txBody>
+      </p:sp>
+      <p:cxnSp>
+        <p:nvCxnSpPr>
+          <p:cNvPr id="47" name="Connector 46"/>
+          <p:cNvCxnSpPr/>
+          <p:nvPr/>
+        </p:nvCxnSpPr>
+        <p:spPr>
+          <a:xfrm>
+            <a:off x="8961120" y="2331720"/>
+            <a:ext cx="457200" cy="45720"/>
+          </a:xfrm>
+          <a:prstGeom prst="bentConnector3">
+            <a:avLst/>
+          </a:prstGeom>
+          <a:ln w="15876">
+            <a:solidFill>
+              <a:srgbClr val="F0F6FC"/>
+            </a:solidFill>
+            <a:tailEnd type="arrow" w="med" len="med"/>
+          </a:ln>
+        </p:spPr>
+        <p:style>
+          <a:lnRef idx="2">
+            <a:schemeClr val="accent1"/>
+          </a:lnRef>
+          <a:fillRef idx="0">
+            <a:schemeClr val="accent1"/>
+          </a:fillRef>
+          <a:effectRef idx="1">
+            <a:schemeClr val="accent1"/>
+          </a:effectRef>
+          <a:fontRef idx="minor">
+            <a:schemeClr val="tx1"/>
+          </a:fontRef>
+        </p:style>
+      </p:cxnSp>
+      <p:sp>
+        <p:nvSpPr>
+          <p:cNvPr id="48" name="Rectangle 47"/>
+          <p:cNvSpPr/>
+          <p:nvPr/>
+        </p:nvSpPr>
+        <p:spPr>
+          <a:xfrm>
+            <a:off x="9061704" y="2226564"/>
+            <a:ext cx="256032" cy="256032"/>
+          </a:xfrm>
+          <a:prstGeom prst="rect">
+            <a:avLst/>
+          </a:prstGeom>
+          <a:solidFill>
+            <a:srgbClr val="F0F6FC"/>
+          </a:solidFill>
+          <a:ln w="9525">
+            <a:solidFill>
+              <a:srgbClr val="F0F6FC"/>
+            </a:solidFill>
+          </a:ln>
+        </p:spPr>
+        <p:style>
+          <a:lnRef idx="1">
+            <a:schemeClr val="accent1"/>
+          </a:lnRef>
+          <a:fillRef idx="3">
+            <a:schemeClr val="accent1"/>
+          </a:fillRef>
+          <a:effectRef idx="2">
+            <a:schemeClr val="accent1"/>
+          </a:effectRef>
+          <a:fontRef idx="minor">
+            <a:schemeClr val="lt1"/>
+          </a:fontRef>
+        </p:style>
+        <p:txBody>
+          <a:bodyPr rtlCol="0" anchor="ctr"/>
+          <a:lstStyle/>
+          <a:p>
+            <a:pPr algn="ctr"/>
+          </a:p>
+        </p:txBody>
+      </p:sp>
+      <p:sp>
+        <p:nvSpPr>
+          <p:cNvPr id="49" name="TextBox 48"/>
+          <p:cNvSpPr txBox="1"/>
+          <p:nvPr/>
+        </p:nvSpPr>
+        <p:spPr>
+          <a:xfrm>
+            <a:off x="9061704" y="2208276"/>
+            <a:ext cx="256032" cy="256032"/>
+          </a:xfrm>
+          <a:prstGeom prst="rect">
+            <a:avLst/>
+          </a:prstGeom>
+          <a:noFill/>
+        </p:spPr>
+        <p:txBody>
+          <a:bodyPr wrap="square">
+            <a:spAutoFit/>
+          </a:bodyPr>
+          <a:lstStyle/>
+          <a:p>
+            <a:pPr algn="ctr"/>
+            <a:r>
+              <a:rPr sz="800" b="1">
+                <a:solidFill>
+                  <a:srgbClr val="0D1117"/>
+                </a:solidFill>
+              </a:rPr>
+              <a:t>5</a:t>
+            </a:r>
+          </a:p>
+        </p:txBody>
+      </p:sp>
+      <p:cxnSp>
+        <p:nvCxnSpPr>
+          <p:cNvPr id="50" name="Connector 49"/>
+          <p:cNvCxnSpPr/>
+          <p:nvPr/>
+        </p:nvCxnSpPr>
+        <p:spPr>
+          <a:xfrm>
+            <a:off x="7726679" y="2834640"/>
+            <a:ext cx="0" cy="868680"/>
+          </a:xfrm>
+          <a:prstGeom prst="bentConnector3">
+            <a:avLst/>
+          </a:prstGeom>
+          <a:ln w="15876">
+            <a:solidFill>
+              <a:srgbClr val="F0883E"/>
+            </a:solidFill>
+            <a:tailEnd type="arrow" w="med" len="med"/>
+          </a:ln>
+        </p:spPr>
+        <p:style>
+          <a:lnRef idx="2">
+            <a:schemeClr val="accent1"/>
+          </a:lnRef>
+          <a:fillRef idx="0">
+            <a:schemeClr val="accent1"/>
+          </a:fillRef>
+          <a:effectRef idx="1">
+            <a:schemeClr val="accent1"/>
+          </a:effectRef>
+          <a:fontRef idx="minor">
+            <a:schemeClr val="tx1"/>
+          </a:fontRef>
+        </p:style>
+      </p:cxnSp>
+      <p:sp>
+        <p:nvSpPr>
+          <p:cNvPr id="51" name="Rectangle 50"/>
+          <p:cNvSpPr/>
+          <p:nvPr/>
+        </p:nvSpPr>
+        <p:spPr>
+          <a:xfrm>
+            <a:off x="7598663" y="3140964"/>
+            <a:ext cx="256032" cy="256032"/>
+          </a:xfrm>
+          <a:prstGeom prst="rect">
+            <a:avLst/>
+          </a:prstGeom>
+          <a:solidFill>
+            <a:srgbClr val="F0883E"/>
+          </a:solidFill>
+          <a:ln w="9525">
+            <a:solidFill>
+              <a:srgbClr val="F0883E"/>
+            </a:solidFill>
+          </a:ln>
+        </p:spPr>
+        <p:style>
+          <a:lnRef idx="1">
+            <a:schemeClr val="accent1"/>
+          </a:lnRef>
+          <a:fillRef idx="3">
+            <a:schemeClr val="accent1"/>
+          </a:fillRef>
+          <a:effectRef idx="2">
+            <a:schemeClr val="accent1"/>
+          </a:effectRef>
+          <a:fontRef idx="minor">
+            <a:schemeClr val="lt1"/>
+          </a:fontRef>
+        </p:style>
+        <p:txBody>
+          <a:bodyPr rtlCol="0" anchor="ctr"/>
+          <a:lstStyle/>
+          <a:p>
+            <a:pPr algn="ctr"/>
+          </a:p>
+        </p:txBody>
+      </p:sp>
+      <p:sp>
+        <p:nvSpPr>
+          <p:cNvPr id="52" name="TextBox 51"/>
+          <p:cNvSpPr txBox="1"/>
+          <p:nvPr/>
+        </p:nvSpPr>
+        <p:spPr>
+          <a:xfrm>
+            <a:off x="7598663" y="3122676"/>
+            <a:ext cx="256032" cy="256032"/>
+          </a:xfrm>
+          <a:prstGeom prst="rect">
+            <a:avLst/>
+          </a:prstGeom>
+          <a:noFill/>
+        </p:spPr>
+        <p:txBody>
+          <a:bodyPr wrap="square">
+            <a:spAutoFit/>
+          </a:bodyPr>
+          <a:lstStyle/>
+          <a:p>
+            <a:pPr algn="ctr"/>
+            <a:r>
+              <a:rPr sz="800" b="1">
+                <a:solidFill>
+                  <a:srgbClr val="0D1117"/>
+                </a:solidFill>
+              </a:rPr>
+              <a:t>6</a:t>
+            </a:r>
+          </a:p>
+        </p:txBody>
+      </p:sp>
+      <p:cxnSp>
+        <p:nvCxnSpPr>
+          <p:cNvPr id="53" name="Connector 52"/>
+          <p:cNvCxnSpPr/>
+          <p:nvPr/>
+        </p:nvCxnSpPr>
+        <p:spPr>
+          <a:xfrm flipV="1">
+            <a:off x="6949440" y="4361688"/>
+            <a:ext cx="365759" cy="347472"/>
+          </a:xfrm>
+          <a:prstGeom prst="bentConnector3">
             <a:avLst/>
           </a:prstGeom>
           <a:ln w="15876">
@@ -16504,84 +17075,131 @@
           </a:fontRef>
         </p:style>
       </p:cxnSp>
-      <p:sp>
-        <p:nvSpPr>
-          <p:cNvPr id="40" name="TextBox 39"/>
-          <p:cNvSpPr txBox="1"/>
-          <p:nvPr/>
-        </p:nvSpPr>
-        <p:spPr>
-          <a:xfrm>
-            <a:off x="7200899" y="4439412"/>
-            <a:ext cx="1645920" cy="292608"/>
-          </a:xfrm>
-          <a:prstGeom prst="rect">
-            <a:avLst/>
-          </a:prstGeom>
-          <a:noFill/>
-        </p:spPr>
-        <p:txBody>
-          <a:bodyPr wrap="square">
-            <a:spAutoFit/>
-          </a:bodyPr>
-          <a:lstStyle/>
-          <a:p>
-            <a:pPr algn="ctr"/>
-            <a:r>
-              <a:rPr sz="800" b="0">
-                <a:solidFill>
-                  <a:srgbClr val="8B949E"/>
-                </a:solidFill>
-              </a:rPr>
-              <a:t>indexed</a:t>
-            </a:r>
-          </a:p>
-        </p:txBody>
-      </p:sp>
-      <p:sp>
-        <p:nvSpPr>
-          <p:cNvPr id="41" name="TextBox 40"/>
-          <p:cNvSpPr txBox="1"/>
-          <p:nvPr/>
-        </p:nvSpPr>
-        <p:spPr>
-          <a:xfrm>
-            <a:off x="365760" y="6492240"/>
-            <a:ext cx="11430000" cy="256032"/>
-          </a:xfrm>
-          <a:prstGeom prst="rect">
-            <a:avLst/>
-          </a:prstGeom>
-          <a:noFill/>
-        </p:spPr>
-        <p:txBody>
-          <a:bodyPr wrap="square">
-            <a:spAutoFit/>
-          </a:bodyPr>
-          <a:lstStyle/>
-          <a:p>
-            <a:pPr algn="ctr"/>
-            <a:r>
-              <a:rPr sz="900" b="0">
-                <a:solidFill>
-                  <a:srgbClr val="8B949E"/>
-                </a:solidFill>
-              </a:rPr>
-              <a:t>All MCP communication via stdio  —  JSON-RPC 2.0  —  no network ports, no cloud</a:t>
-            </a:r>
-          </a:p>
-        </p:txBody>
-      </p:sp>
-      <p:sp>
-        <p:nvSpPr>
-          <p:cNvPr id="42" name="Rectangle 41"/>
+      <p:cxnSp>
+        <p:nvCxnSpPr>
+          <p:cNvPr id="54" name="Connector 53"/>
+          <p:cNvCxnSpPr/>
+          <p:nvPr/>
+        </p:nvCxnSpPr>
+        <p:spPr>
+          <a:xfrm flipH="1" flipV="1">
+            <a:off x="8138159" y="4361688"/>
+            <a:ext cx="822960" cy="347472"/>
+          </a:xfrm>
+          <a:prstGeom prst="bentConnector3">
+            <a:avLst/>
+          </a:prstGeom>
+          <a:ln w="15876">
+            <a:solidFill>
+              <a:srgbClr val="8B949E"/>
+            </a:solidFill>
+            <a:tailEnd type="arrow" w="med" len="med"/>
+          </a:ln>
+        </p:spPr>
+        <p:style>
+          <a:lnRef idx="2">
+            <a:schemeClr val="accent1"/>
+          </a:lnRef>
+          <a:fillRef idx="0">
+            <a:schemeClr val="accent1"/>
+          </a:fillRef>
+          <a:effectRef idx="1">
+            <a:schemeClr val="accent1"/>
+          </a:effectRef>
+          <a:fontRef idx="minor">
+            <a:schemeClr val="tx1"/>
+          </a:fontRef>
+        </p:style>
+      </p:cxnSp>
+      <p:sp>
+        <p:nvSpPr>
+          <p:cNvPr id="55" name="Rectangle 54"/>
           <p:cNvSpPr/>
           <p:nvPr/>
         </p:nvSpPr>
         <p:spPr>
           <a:xfrm>
-            <a:off x="365760" y="6144768"/>
-            <a:ext cx="164592" cy="164592"/>
+            <a:off x="7004304" y="4407408"/>
+            <a:ext cx="256032" cy="256032"/>
+          </a:xfrm>
+          <a:prstGeom prst="rect">
+            <a:avLst/>
+          </a:prstGeom>
+          <a:solidFill>
+            <a:srgbClr val="8B949E"/>
+          </a:solidFill>
+          <a:ln w="9525">
+            <a:solidFill>
+              <a:srgbClr val="8B949E"/>
+            </a:solidFill>
+          </a:ln>
+        </p:spPr>
+        <p:style>
+          <a:lnRef idx="1">
+            <a:schemeClr val="accent1"/>
+          </a:lnRef>
+          <a:fillRef idx="3">
+            <a:schemeClr val="accent1"/>
+          </a:fillRef>
+          <a:effectRef idx="2">
+            <a:schemeClr val="accent1"/>
+          </a:effectRef>
+          <a:fontRef idx="minor">
+            <a:schemeClr val="lt1"/>
+          </a:fontRef>
+        </p:style>
+        <p:txBody>
+          <a:bodyPr rtlCol="0" anchor="ctr"/>
+          <a:lstStyle/>
+          <a:p>
+            <a:pPr algn="ctr"/>
+          </a:p>
+        </p:txBody>
+      </p:sp>
+      <p:sp>
+        <p:nvSpPr>
+          <p:cNvPr id="56" name="TextBox 55"/>
+          <p:cNvSpPr txBox="1"/>
+          <p:nvPr/>
+        </p:nvSpPr>
+        <p:spPr>
+          <a:xfrm>
+            <a:off x="7004304" y="4389120"/>
+            <a:ext cx="256032" cy="256032"/>
+          </a:xfrm>
+          <a:prstGeom prst="rect">
+            <a:avLst/>
+          </a:prstGeom>
+          <a:noFill/>
+        </p:spPr>
+        <p:txBody>
+          <a:bodyPr wrap="square">
+            <a:spAutoFit/>
+          </a:bodyPr>
+          <a:lstStyle/>
+          <a:p>
+            <a:pPr algn="ctr"/>
+            <a:r>
+              <a:rPr sz="800" b="1">
+                <a:solidFill>
+                  <a:srgbClr val="0D1117"/>
+                </a:solidFill>
+              </a:rPr>
+              <a:t>7</a:t>
+            </a:r>
+          </a:p>
+        </p:txBody>
+      </p:sp>
+      <p:sp>
+        <p:nvSpPr>
+          <p:cNvPr id="57" name="Rectangle 56"/>
+          <p:cNvSpPr/>
+          <p:nvPr/>
+        </p:nvSpPr>
+        <p:spPr>
+          <a:xfrm>
+            <a:off x="228600" y="5650992"/>
+            <a:ext cx="201168" cy="141732"/>
           </a:xfrm>
           <a:prstGeom prst="rect">
             <a:avLst/>
@@ -16619,14 +17237,14 @@
       </p:sp>
       <p:sp>
         <p:nvSpPr>
-          <p:cNvPr id="43" name="TextBox 42"/>
-          <p:cNvSpPr txBox="1"/>
-          <p:nvPr/>
-        </p:nvSpPr>
-        <p:spPr>
-          <a:xfrm>
-            <a:off x="566928" y="6135624"/>
-            <a:ext cx="1920240" cy="201168"/>
+          <p:cNvPr id="58" name="TextBox 57"/>
+          <p:cNvSpPr txBox="1"/>
+          <p:nvPr/>
+        </p:nvSpPr>
+        <p:spPr>
+          <a:xfrm>
+            <a:off x="475488" y="5641848"/>
+            <a:ext cx="5486400" cy="164592"/>
           </a:xfrm>
           <a:prstGeom prst="rect">
             <a:avLst/>
@@ -16641,26 +17259,105 @@
           <a:p>
             <a:pPr algn="l"/>
             <a:r>
-              <a:rPr sz="900" b="0">
+              <a:rPr sz="750" b="0">
                 <a:solidFill>
                   <a:srgbClr val="8B949E"/>
                 </a:solidFill>
               </a:rPr>
-              <a:t>AI Interface</a:t>
-            </a:r>
-          </a:p>
-        </p:txBody>
-      </p:sp>
-      <p:sp>
-        <p:nvSpPr>
-          <p:cNvPr id="44" name="Rectangle 43"/>
+              <a:t>1  get_relevant_repos(query_text)  →  [repo1, repo2]  (MCP/stdio, JSON-RPC 2.0)</a:t>
+            </a:r>
+          </a:p>
+        </p:txBody>
+      </p:sp>
+      <p:sp>
+        <p:nvSpPr>
+          <p:cNvPr id="59" name="Rectangle 58"/>
           <p:cNvSpPr/>
           <p:nvPr/>
         </p:nvSpPr>
         <p:spPr>
           <a:xfrm>
-            <a:off x="2697480" y="6144768"/>
-            <a:ext cx="164592" cy="164592"/>
+            <a:off x="228600" y="5820156"/>
+            <a:ext cx="201168" cy="141732"/>
+          </a:xfrm>
+          <a:prstGeom prst="rect">
+            <a:avLst/>
+          </a:prstGeom>
+          <a:solidFill>
+            <a:srgbClr val="58A6FF"/>
+          </a:solidFill>
+          <a:ln w="9525">
+            <a:solidFill>
+              <a:srgbClr val="58A6FF"/>
+            </a:solidFill>
+          </a:ln>
+        </p:spPr>
+        <p:style>
+          <a:lnRef idx="1">
+            <a:schemeClr val="accent1"/>
+          </a:lnRef>
+          <a:fillRef idx="3">
+            <a:schemeClr val="accent1"/>
+          </a:fillRef>
+          <a:effectRef idx="2">
+            <a:schemeClr val="accent1"/>
+          </a:effectRef>
+          <a:fontRef idx="minor">
+            <a:schemeClr val="lt1"/>
+          </a:fontRef>
+        </p:style>
+        <p:txBody>
+          <a:bodyPr rtlCol="0" anchor="ctr"/>
+          <a:lstStyle/>
+          <a:p>
+            <a:pPr algn="ctr"/>
+          </a:p>
+        </p:txBody>
+      </p:sp>
+      <p:sp>
+        <p:nvSpPr>
+          <p:cNvPr id="60" name="TextBox 59"/>
+          <p:cNvSpPr txBox="1"/>
+          <p:nvPr/>
+        </p:nvSpPr>
+        <p:spPr>
+          <a:xfrm>
+            <a:off x="475488" y="5811012"/>
+            <a:ext cx="5486400" cy="164592"/>
+          </a:xfrm>
+          <a:prstGeom prst="rect">
+            <a:avLst/>
+          </a:prstGeom>
+          <a:noFill/>
+        </p:spPr>
+        <p:txBody>
+          <a:bodyPr wrap="square">
+            <a:spAutoFit/>
+          </a:bodyPr>
+          <a:lstStyle/>
+          <a:p>
+            <a:pPr algn="l"/>
+            <a:r>
+              <a:rPr sz="750" b="0">
+                <a:solidFill>
+                  <a:srgbClr val="8B949E"/>
+                </a:solidFill>
+              </a:rPr>
+              <a:t>2  query_repo(feature_request)  →  RELEVANT KNOWLEDGE:...  (MCP/stdio, ×3 calls)</a:t>
+            </a:r>
+          </a:p>
+        </p:txBody>
+      </p:sp>
+      <p:sp>
+        <p:nvSpPr>
+          <p:cNvPr id="61" name="Rectangle 60"/>
+          <p:cNvSpPr/>
+          <p:nvPr/>
+        </p:nvSpPr>
+        <p:spPr>
+          <a:xfrm>
+            <a:off x="228600" y="5989320"/>
+            <a:ext cx="201168" cy="141732"/>
           </a:xfrm>
           <a:prstGeom prst="rect">
             <a:avLst/>
@@ -16698,14 +17395,14 @@
       </p:sp>
       <p:sp>
         <p:nvSpPr>
-          <p:cNvPr id="45" name="TextBox 44"/>
-          <p:cNvSpPr txBox="1"/>
-          <p:nvPr/>
-        </p:nvSpPr>
-        <p:spPr>
-          <a:xfrm>
-            <a:off x="2898648" y="6135624"/>
-            <a:ext cx="1920240" cy="201168"/>
+          <p:cNvPr id="62" name="TextBox 61"/>
+          <p:cNvSpPr txBox="1"/>
+          <p:nvPr/>
+        </p:nvSpPr>
+        <p:spPr>
+          <a:xfrm>
+            <a:off x="475488" y="5980176"/>
+            <a:ext cx="5486400" cy="164592"/>
           </a:xfrm>
           <a:prstGeom prst="rect">
             <a:avLst/>
@@ -16720,26 +17417,26 @@
           <a:p>
             <a:pPr algn="l"/>
             <a:r>
-              <a:rPr sz="900" b="0">
+              <a:rPr sz="750" b="0">
                 <a:solidFill>
                   <a:srgbClr val="8B949E"/>
                 </a:solidFill>
               </a:rPr>
-              <a:t>Orchestrator / Storage</a:t>
-            </a:r>
-          </a:p>
-        </p:txBody>
-      </p:sp>
-      <p:sp>
-        <p:nvSpPr>
-          <p:cNvPr id="46" name="Rectangle 45"/>
+              <a:t>3  route  →  query_repo on all repos  →  min(len/800, 1.0) score, return top-2</a:t>
+            </a:r>
+          </a:p>
+        </p:txBody>
+      </p:sp>
+      <p:sp>
+        <p:nvSpPr>
+          <p:cNvPr id="63" name="Rectangle 62"/>
           <p:cNvSpPr/>
           <p:nvPr/>
         </p:nvSpPr>
         <p:spPr>
           <a:xfrm>
-            <a:off x="5029200" y="6144768"/>
-            <a:ext cx="164592" cy="164592"/>
+            <a:off x="228600" y="6158484"/>
+            <a:ext cx="201168" cy="141732"/>
           </a:xfrm>
           <a:prstGeom prst="rect">
             <a:avLst/>
@@ -16777,14 +17474,14 @@
       </p:sp>
       <p:sp>
         <p:nvSpPr>
-          <p:cNvPr id="47" name="TextBox 46"/>
-          <p:cNvSpPr txBox="1"/>
-          <p:nvPr/>
-        </p:nvSpPr>
-        <p:spPr>
-          <a:xfrm>
-            <a:off x="5230368" y="6135624"/>
-            <a:ext cx="1920240" cy="201168"/>
+          <p:cNvPr id="64" name="TextBox 63"/>
+          <p:cNvSpPr txBox="1"/>
+          <p:nvPr/>
+        </p:nvSpPr>
+        <p:spPr>
+          <a:xfrm>
+            <a:off x="475488" y="6149340"/>
+            <a:ext cx="5486400" cy="164592"/>
           </a:xfrm>
           <a:prstGeom prst="rect">
             <a:avLst/>
@@ -16799,26 +17496,105 @@
           <a:p>
             <a:pPr algn="l"/>
             <a:r>
-              <a:rPr sz="900" b="0">
+              <a:rPr sz="750" b="0">
                 <a:solidFill>
                   <a:srgbClr val="8B949E"/>
                 </a:solidFill>
               </a:rPr>
-              <a:t>Repo Agent  (MCP server)</a:t>
-            </a:r>
-          </a:p>
-        </p:txBody>
-      </p:sp>
-      <p:sp>
-        <p:nvSpPr>
-          <p:cNvPr id="48" name="Rectangle 47"/>
+              <a:t>4  query(feature_request)  →  chunks + L2 distances  (internal, per-agent)</a:t>
+            </a:r>
+          </a:p>
+        </p:txBody>
+      </p:sp>
+      <p:sp>
+        <p:nvSpPr>
+          <p:cNvPr id="65" name="Rectangle 64"/>
           <p:cNvSpPr/>
           <p:nvPr/>
         </p:nvSpPr>
         <p:spPr>
           <a:xfrm>
-            <a:off x="7360920" y="6144768"/>
-            <a:ext cx="164592" cy="164592"/>
+            <a:off x="6217920" y="5650992"/>
+            <a:ext cx="201168" cy="141732"/>
+          </a:xfrm>
+          <a:prstGeom prst="rect">
+            <a:avLst/>
+          </a:prstGeom>
+          <a:solidFill>
+            <a:srgbClr val="F0F6FC"/>
+          </a:solidFill>
+          <a:ln w="9525">
+            <a:solidFill>
+              <a:srgbClr val="F0F6FC"/>
+            </a:solidFill>
+          </a:ln>
+        </p:spPr>
+        <p:style>
+          <a:lnRef idx="1">
+            <a:schemeClr val="accent1"/>
+          </a:lnRef>
+          <a:fillRef idx="3">
+            <a:schemeClr val="accent1"/>
+          </a:fillRef>
+          <a:effectRef idx="2">
+            <a:schemeClr val="accent1"/>
+          </a:effectRef>
+          <a:fontRef idx="minor">
+            <a:schemeClr val="lt1"/>
+          </a:fontRef>
+        </p:style>
+        <p:txBody>
+          <a:bodyPr rtlCol="0" anchor="ctr"/>
+          <a:lstStyle/>
+          <a:p>
+            <a:pPr algn="ctr"/>
+          </a:p>
+        </p:txBody>
+      </p:sp>
+      <p:sp>
+        <p:nvSpPr>
+          <p:cNvPr id="66" name="TextBox 65"/>
+          <p:cNvSpPr txBox="1"/>
+          <p:nvPr/>
+        </p:nvSpPr>
+        <p:spPr>
+          <a:xfrm>
+            <a:off x="6464808" y="5641848"/>
+            <a:ext cx="5486400" cy="164592"/>
+          </a:xfrm>
+          <a:prstGeom prst="rect">
+            <a:avLst/>
+          </a:prstGeom>
+          <a:noFill/>
+        </p:spPr>
+        <p:txBody>
+          <a:bodyPr wrap="square">
+            <a:spAutoFit/>
+          </a:bodyPr>
+          <a:lstStyle/>
+          <a:p>
+            <a:pPr algn="l"/>
+            <a:r>
+              <a:rPr sz="750" b="0">
+                <a:solidFill>
+                  <a:srgbClr val="8B949E"/>
+                </a:solidFill>
+              </a:rPr>
+              <a:t>5  encode(text)  →  384-dim float[]  (sentence-transformers, local CPU/GPU)</a:t>
+            </a:r>
+          </a:p>
+        </p:txBody>
+      </p:sp>
+      <p:sp>
+        <p:nvSpPr>
+          <p:cNvPr id="67" name="Rectangle 66"/>
+          <p:cNvSpPr/>
+          <p:nvPr/>
+        </p:nvSpPr>
+        <p:spPr>
+          <a:xfrm>
+            <a:off x="6217920" y="5820156"/>
+            <a:ext cx="201168" cy="141732"/>
           </a:xfrm>
           <a:prstGeom prst="rect">
             <a:avLst/>
@@ -16856,14 +17632,14 @@
       </p:sp>
       <p:sp>
         <p:nvSpPr>
-          <p:cNvPr id="49" name="TextBox 48"/>
-          <p:cNvSpPr txBox="1"/>
-          <p:nvPr/>
-        </p:nvSpPr>
-        <p:spPr>
-          <a:xfrm>
-            <a:off x="7562088" y="6135624"/>
-            <a:ext cx="1920240" cy="201168"/>
+          <p:cNvPr id="68" name="TextBox 67"/>
+          <p:cNvSpPr txBox="1"/>
+          <p:nvPr/>
+        </p:nvSpPr>
+        <p:spPr>
+          <a:xfrm>
+            <a:off x="6464808" y="5811012"/>
+            <a:ext cx="5486400" cy="164592"/>
           </a:xfrm>
           <a:prstGeom prst="rect">
             <a:avLst/>
@@ -16878,26 +17654,26 @@
           <a:p>
             <a:pPr algn="l"/>
             <a:r>
-              <a:rPr sz="900" b="0">
+              <a:rPr sz="750" b="0">
                 <a:solidFill>
                   <a:srgbClr val="8B949E"/>
                 </a:solidFill>
               </a:rPr>
-              <a:t>RAG Engine</a:t>
-            </a:r>
-          </a:p>
-        </p:txBody>
-      </p:sp>
-      <p:sp>
-        <p:nvSpPr>
-          <p:cNvPr id="50" name="Rectangle 49"/>
+              <a:t>6  vector similarity search  →  top-k chunks + L2 dist  (ChromaDB)</a:t>
+            </a:r>
+          </a:p>
+        </p:txBody>
+      </p:sp>
+      <p:sp>
+        <p:nvSpPr>
+          <p:cNvPr id="69" name="Rectangle 68"/>
           <p:cNvSpPr/>
           <p:nvPr/>
         </p:nvSpPr>
         <p:spPr>
           <a:xfrm>
-            <a:off x="9692640" y="6144768"/>
-            <a:ext cx="164592" cy="164592"/>
+            <a:off x="6217920" y="5989320"/>
+            <a:ext cx="201168" cy="141732"/>
           </a:xfrm>
           <a:prstGeom prst="rect">
             <a:avLst/>
@@ -16935,14 +17711,14 @@
       </p:sp>
       <p:sp>
         <p:nvSpPr>
-          <p:cNvPr id="51" name="TextBox 50"/>
-          <p:cNvSpPr txBox="1"/>
-          <p:nvPr/>
-        </p:nvSpPr>
-        <p:spPr>
-          <a:xfrm>
-            <a:off x="9893808" y="6135624"/>
-            <a:ext cx="1920240" cy="201168"/>
+          <p:cNvPr id="70" name="TextBox 69"/>
+          <p:cNvSpPr txBox="1"/>
+          <p:nvPr/>
+        </p:nvSpPr>
+        <p:spPr>
+          <a:xfrm>
+            <a:off x="6464808" y="5980176"/>
+            <a:ext cx="5486400" cy="164592"/>
           </a:xfrm>
           <a:prstGeom prst="rect">
             <a:avLst/>
@@ -16957,12 +17733,12 @@
           <a:p>
             <a:pPr algn="l"/>
             <a:r>
-              <a:rPr sz="900" b="0">
+              <a:rPr sz="750" b="0">
                 <a:solidFill>
                   <a:srgbClr val="8B949E"/>
                 </a:solidFill>
               </a:rPr>
-              <a:t>Data Source</a:t>
+              <a:t>7  indexed at startup  →  text split → embed → stored in .chroma_db/</a:t>
             </a:r>
           </a:p>
         </p:txBody>

</xml_diff>

<commit_message>
Fix data flow: place Embedding Model between RAG Engine and ChromaDB
All vectors entering ChromaDB (indexing) and all query vectors leaving
toward ChromaDB (search) now flow through the Embedding Model, which
is the architecturally correct position.

Right column now reads top-to-bottom:
  RAG Engine → ⑤ → Embedding Model → ⑥ → ChromaDB
  Docs/Source → ⑦ → Embedding Model (startup indexing path)

Co-Authored-By: Claude Sonnet 4.6 <noreply@anthropic.com>
</commit_message>
<xml_diff>
--- a/demo/slides.pptx
+++ b/demo/slides.pptx
@@ -15659,8 +15659,8 @@
         </p:nvSpPr>
         <p:spPr>
           <a:xfrm>
-            <a:off x="6492240" y="1828800"/>
-            <a:ext cx="2468880" cy="1005840"/>
+            <a:off x="6492240" y="1600200"/>
+            <a:ext cx="2468880" cy="777240"/>
           </a:xfrm>
           <a:prstGeom prst="rect">
             <a:avLst/>
@@ -15704,8 +15704,8 @@
         </p:nvSpPr>
         <p:spPr>
           <a:xfrm>
-            <a:off x="6537959" y="1920240"/>
-            <a:ext cx="2377440" cy="822960"/>
+            <a:off x="6537959" y="1673352"/>
+            <a:ext cx="2377440" cy="630936"/>
           </a:xfrm>
           <a:prstGeom prst="rect">
             <a:avLst/>
@@ -15740,8 +15740,8 @@
         </p:nvSpPr>
         <p:spPr>
           <a:xfrm>
-            <a:off x="9418320" y="1920240"/>
-            <a:ext cx="2560320" cy="914400"/>
+            <a:off x="6492240" y="2560320"/>
+            <a:ext cx="2468880" cy="713232"/>
           </a:xfrm>
           <a:prstGeom prst="rect">
             <a:avLst/>
@@ -15785,8 +15785,8 @@
         </p:nvSpPr>
         <p:spPr>
           <a:xfrm>
-            <a:off x="9464040" y="2011680"/>
-            <a:ext cx="2468879" cy="731520"/>
+            <a:off x="6537959" y="2633472"/>
+            <a:ext cx="2377440" cy="566928"/>
           </a:xfrm>
           <a:prstGeom prst="rect">
             <a:avLst/>
@@ -15821,7 +15821,7 @@
         </p:nvSpPr>
         <p:spPr>
           <a:xfrm>
-            <a:off x="6492240" y="3703320"/>
+            <a:off x="6492240" y="3474720"/>
             <a:ext cx="2468880" cy="658368"/>
           </a:xfrm>
           <a:prstGeom prst="rect">
@@ -15866,7 +15866,7 @@
         </p:nvSpPr>
         <p:spPr>
           <a:xfrm>
-            <a:off x="6537959" y="3776472"/>
+            <a:off x="6537959" y="3547872"/>
             <a:ext cx="2377440" cy="512063"/>
           </a:xfrm>
           <a:prstGeom prst="rect">
@@ -15901,7 +15901,7 @@
         </p:nvSpPr>
         <p:spPr>
           <a:xfrm>
-            <a:off x="6080760" y="4709160"/>
+            <a:off x="6080760" y="4617720"/>
             <a:ext cx="1737360" cy="566928"/>
           </a:xfrm>
           <a:prstGeom prst="rect">
@@ -15946,7 +15946,7 @@
         </p:nvSpPr>
         <p:spPr>
           <a:xfrm>
-            <a:off x="6108192" y="4764024"/>
+            <a:off x="6108192" y="4672583"/>
             <a:ext cx="1682495" cy="457200"/>
           </a:xfrm>
           <a:prstGeom prst="rect">
@@ -15981,7 +15981,7 @@
         </p:nvSpPr>
         <p:spPr>
           <a:xfrm>
-            <a:off x="8092440" y="4709160"/>
+            <a:off x="8092440" y="4617720"/>
             <a:ext cx="1737360" cy="566928"/>
           </a:xfrm>
           <a:prstGeom prst="rect">
@@ -16026,7 +16026,7 @@
         </p:nvSpPr>
         <p:spPr>
           <a:xfrm>
-            <a:off x="8119871" y="4764024"/>
+            <a:off x="8119871" y="4672583"/>
             <a:ext cx="1682495" cy="457200"/>
           </a:xfrm>
           <a:prstGeom prst="rect">
@@ -16061,8 +16061,8 @@
         </p:nvSpPr>
         <p:spPr>
           <a:xfrm>
-            <a:off x="9418320" y="3611880"/>
-            <a:ext cx="2560320" cy="1463040"/>
+            <a:off x="9418320" y="1600200"/>
+            <a:ext cx="2560320" cy="1874519"/>
           </a:xfrm>
           <a:prstGeom prst="rect">
             <a:avLst/>
@@ -16106,7 +16106,7 @@
         </p:nvSpPr>
         <p:spPr>
           <a:xfrm>
-            <a:off x="9491472" y="3685032"/>
+            <a:off x="9491472" y="1673352"/>
             <a:ext cx="2414015" cy="228600"/>
           </a:xfrm>
           <a:prstGeom prst="rect">
@@ -16140,8 +16140,8 @@
         </p:nvSpPr>
         <p:spPr>
           <a:xfrm>
-            <a:off x="9491472" y="3959352"/>
-            <a:ext cx="2414015" cy="1005840"/>
+            <a:off x="9491472" y="1947672"/>
+            <a:ext cx="2414015" cy="1417319"/>
           </a:xfrm>
           <a:prstGeom prst="rect">
             <a:avLst/>
@@ -16295,7 +16295,7 @@
         <p:spPr>
           <a:xfrm flipH="1">
             <a:off x="4480560" y="1325880"/>
-            <a:ext cx="1645919" cy="64008"/>
+            <a:ext cx="1554480" cy="1303020"/>
           </a:xfrm>
           <a:prstGeom prst="bentConnector3">
             <a:avLst/>
@@ -16330,7 +16330,7 @@
         </p:nvSpPr>
         <p:spPr>
           <a:xfrm>
-            <a:off x="5175504" y="1229867"/>
+            <a:off x="5129784" y="1849374"/>
             <a:ext cx="256032" cy="256032"/>
           </a:xfrm>
           <a:prstGeom prst="rect">
@@ -16375,7 +16375,7 @@
         </p:nvSpPr>
         <p:spPr>
           <a:xfrm>
-            <a:off x="5175504" y="1211580"/>
+            <a:off x="5129784" y="1831086"/>
             <a:ext cx="256032" cy="256032"/>
           </a:xfrm>
           <a:prstGeom prst="rect">
@@ -16409,7 +16409,7 @@
         </p:nvSpPr>
         <p:spPr>
           <a:xfrm>
-            <a:off x="5413248" y="1266443"/>
+            <a:off x="5385816" y="1867662"/>
             <a:ext cx="320040" cy="201168"/>
           </a:xfrm>
           <a:prstGeom prst="rect">
@@ -16631,7 +16631,7 @@
         <p:spPr>
           <a:xfrm>
             <a:off x="5760720" y="1687068"/>
-            <a:ext cx="731520" cy="644652"/>
+            <a:ext cx="731520" cy="301751"/>
           </a:xfrm>
           <a:prstGeom prst="bentConnector3">
             <a:avLst/>
@@ -16666,8 +16666,8 @@
         </p:nvCxnSpPr>
         <p:spPr>
           <a:xfrm flipV="1">
-            <a:off x="5760720" y="2331720"/>
-            <a:ext cx="731520" cy="297180"/>
+            <a:off x="5760720" y="1988819"/>
+            <a:ext cx="731520" cy="640081"/>
           </a:xfrm>
           <a:prstGeom prst="bentConnector3">
             <a:avLst/>
@@ -16702,8 +16702,8 @@
         </p:nvCxnSpPr>
         <p:spPr>
           <a:xfrm flipV="1">
-            <a:off x="5760720" y="2331720"/>
-            <a:ext cx="731520" cy="1239012"/>
+            <a:off x="5760720" y="1988819"/>
+            <a:ext cx="731520" cy="1581913"/>
           </a:xfrm>
           <a:prstGeom prst="bentConnector3">
             <a:avLst/>
@@ -16738,7 +16738,7 @@
         </p:nvSpPr>
         <p:spPr>
           <a:xfrm>
-            <a:off x="5998464" y="2352294"/>
+            <a:off x="5998464" y="2180844"/>
             <a:ext cx="256032" cy="256032"/>
           </a:xfrm>
           <a:prstGeom prst="rect">
@@ -16783,7 +16783,7 @@
         </p:nvSpPr>
         <p:spPr>
           <a:xfrm>
-            <a:off x="5998464" y="2334006"/>
+            <a:off x="5998464" y="2162556"/>
             <a:ext cx="256032" cy="256032"/>
           </a:xfrm>
           <a:prstGeom prst="rect">
@@ -16817,15 +16817,15 @@
         </p:nvCxnSpPr>
         <p:spPr>
           <a:xfrm>
-            <a:off x="8961120" y="2331720"/>
-            <a:ext cx="457200" cy="45720"/>
+            <a:off x="7726679" y="2377440"/>
+            <a:ext cx="0" cy="182880"/>
           </a:xfrm>
           <a:prstGeom prst="bentConnector3">
             <a:avLst/>
           </a:prstGeom>
           <a:ln w="15876">
             <a:solidFill>
-              <a:srgbClr val="F0F6FC"/>
+              <a:srgbClr val="F0883E"/>
             </a:solidFill>
             <a:tailEnd type="arrow" w="med" len="med"/>
           </a:ln>
@@ -16853,122 +16853,7 @@
         </p:nvSpPr>
         <p:spPr>
           <a:xfrm>
-            <a:off x="9061704" y="2226564"/>
-            <a:ext cx="256032" cy="256032"/>
-          </a:xfrm>
-          <a:prstGeom prst="rect">
-            <a:avLst/>
-          </a:prstGeom>
-          <a:solidFill>
-            <a:srgbClr val="F0F6FC"/>
-          </a:solidFill>
-          <a:ln w="9525">
-            <a:solidFill>
-              <a:srgbClr val="F0F6FC"/>
-            </a:solidFill>
-          </a:ln>
-        </p:spPr>
-        <p:style>
-          <a:lnRef idx="1">
-            <a:schemeClr val="accent1"/>
-          </a:lnRef>
-          <a:fillRef idx="3">
-            <a:schemeClr val="accent1"/>
-          </a:fillRef>
-          <a:effectRef idx="2">
-            <a:schemeClr val="accent1"/>
-          </a:effectRef>
-          <a:fontRef idx="minor">
-            <a:schemeClr val="lt1"/>
-          </a:fontRef>
-        </p:style>
-        <p:txBody>
-          <a:bodyPr rtlCol="0" anchor="ctr"/>
-          <a:lstStyle/>
-          <a:p>
-            <a:pPr algn="ctr"/>
-          </a:p>
-        </p:txBody>
-      </p:sp>
-      <p:sp>
-        <p:nvSpPr>
-          <p:cNvPr id="49" name="TextBox 48"/>
-          <p:cNvSpPr txBox="1"/>
-          <p:nvPr/>
-        </p:nvSpPr>
-        <p:spPr>
-          <a:xfrm>
-            <a:off x="9061704" y="2208276"/>
-            <a:ext cx="256032" cy="256032"/>
-          </a:xfrm>
-          <a:prstGeom prst="rect">
-            <a:avLst/>
-          </a:prstGeom>
-          <a:noFill/>
-        </p:spPr>
-        <p:txBody>
-          <a:bodyPr wrap="square">
-            <a:spAutoFit/>
-          </a:bodyPr>
-          <a:lstStyle/>
-          <a:p>
-            <a:pPr algn="ctr"/>
-            <a:r>
-              <a:rPr sz="800" b="1">
-                <a:solidFill>
-                  <a:srgbClr val="0D1117"/>
-                </a:solidFill>
-              </a:rPr>
-              <a:t>5</a:t>
-            </a:r>
-          </a:p>
-        </p:txBody>
-      </p:sp>
-      <p:cxnSp>
-        <p:nvCxnSpPr>
-          <p:cNvPr id="50" name="Connector 49"/>
-          <p:cNvCxnSpPr/>
-          <p:nvPr/>
-        </p:nvCxnSpPr>
-        <p:spPr>
-          <a:xfrm>
-            <a:off x="7726679" y="2834640"/>
-            <a:ext cx="0" cy="868680"/>
-          </a:xfrm>
-          <a:prstGeom prst="bentConnector3">
-            <a:avLst/>
-          </a:prstGeom>
-          <a:ln w="15876">
-            <a:solidFill>
-              <a:srgbClr val="F0883E"/>
-            </a:solidFill>
-            <a:tailEnd type="arrow" w="med" len="med"/>
-          </a:ln>
-        </p:spPr>
-        <p:style>
-          <a:lnRef idx="2">
-            <a:schemeClr val="accent1"/>
-          </a:lnRef>
-          <a:fillRef idx="0">
-            <a:schemeClr val="accent1"/>
-          </a:fillRef>
-          <a:effectRef idx="1">
-            <a:schemeClr val="accent1"/>
-          </a:effectRef>
-          <a:fontRef idx="minor">
-            <a:schemeClr val="tx1"/>
-          </a:fontRef>
-        </p:style>
-      </p:cxnSp>
-      <p:sp>
-        <p:nvSpPr>
-          <p:cNvPr id="51" name="Rectangle 50"/>
-          <p:cNvSpPr/>
-          <p:nvPr/>
-        </p:nvSpPr>
-        <p:spPr>
-          <a:xfrm>
-            <a:off x="7598663" y="3140964"/>
+            <a:off x="7598663" y="2340864"/>
             <a:ext cx="256032" cy="256032"/>
           </a:xfrm>
           <a:prstGeom prst="rect">
@@ -17007,13 +16892,128 @@
       </p:sp>
       <p:sp>
         <p:nvSpPr>
+          <p:cNvPr id="49" name="TextBox 48"/>
+          <p:cNvSpPr txBox="1"/>
+          <p:nvPr/>
+        </p:nvSpPr>
+        <p:spPr>
+          <a:xfrm>
+            <a:off x="7598663" y="2322576"/>
+            <a:ext cx="256032" cy="256032"/>
+          </a:xfrm>
+          <a:prstGeom prst="rect">
+            <a:avLst/>
+          </a:prstGeom>
+          <a:noFill/>
+        </p:spPr>
+        <p:txBody>
+          <a:bodyPr wrap="square">
+            <a:spAutoFit/>
+          </a:bodyPr>
+          <a:lstStyle/>
+          <a:p>
+            <a:pPr algn="ctr"/>
+            <a:r>
+              <a:rPr sz="800" b="1">
+                <a:solidFill>
+                  <a:srgbClr val="0D1117"/>
+                </a:solidFill>
+              </a:rPr>
+              <a:t>5</a:t>
+            </a:r>
+          </a:p>
+        </p:txBody>
+      </p:sp>
+      <p:cxnSp>
+        <p:nvCxnSpPr>
+          <p:cNvPr id="50" name="Connector 49"/>
+          <p:cNvCxnSpPr/>
+          <p:nvPr/>
+        </p:nvCxnSpPr>
+        <p:spPr>
+          <a:xfrm>
+            <a:off x="7726679" y="3273552"/>
+            <a:ext cx="0" cy="201168"/>
+          </a:xfrm>
+          <a:prstGeom prst="bentConnector3">
+            <a:avLst/>
+          </a:prstGeom>
+          <a:ln w="15876">
+            <a:solidFill>
+              <a:srgbClr val="58A6FF"/>
+            </a:solidFill>
+            <a:tailEnd type="arrow" w="med" len="med"/>
+          </a:ln>
+        </p:spPr>
+        <p:style>
+          <a:lnRef idx="2">
+            <a:schemeClr val="accent1"/>
+          </a:lnRef>
+          <a:fillRef idx="0">
+            <a:schemeClr val="accent1"/>
+          </a:fillRef>
+          <a:effectRef idx="1">
+            <a:schemeClr val="accent1"/>
+          </a:effectRef>
+          <a:fontRef idx="minor">
+            <a:schemeClr val="tx1"/>
+          </a:fontRef>
+        </p:style>
+      </p:cxnSp>
+      <p:sp>
+        <p:nvSpPr>
+          <p:cNvPr id="51" name="Rectangle 50"/>
+          <p:cNvSpPr/>
+          <p:nvPr/>
+        </p:nvSpPr>
+        <p:spPr>
+          <a:xfrm>
+            <a:off x="7598663" y="3246120"/>
+            <a:ext cx="256032" cy="256032"/>
+          </a:xfrm>
+          <a:prstGeom prst="rect">
+            <a:avLst/>
+          </a:prstGeom>
+          <a:solidFill>
+            <a:srgbClr val="58A6FF"/>
+          </a:solidFill>
+          <a:ln w="9525">
+            <a:solidFill>
+              <a:srgbClr val="58A6FF"/>
+            </a:solidFill>
+          </a:ln>
+        </p:spPr>
+        <p:style>
+          <a:lnRef idx="1">
+            <a:schemeClr val="accent1"/>
+          </a:lnRef>
+          <a:fillRef idx="3">
+            <a:schemeClr val="accent1"/>
+          </a:fillRef>
+          <a:effectRef idx="2">
+            <a:schemeClr val="accent1"/>
+          </a:effectRef>
+          <a:fontRef idx="minor">
+            <a:schemeClr val="lt1"/>
+          </a:fontRef>
+        </p:style>
+        <p:txBody>
+          <a:bodyPr rtlCol="0" anchor="ctr"/>
+          <a:lstStyle/>
+          <a:p>
+            <a:pPr algn="ctr"/>
+          </a:p>
+        </p:txBody>
+      </p:sp>
+      <p:sp>
+        <p:nvSpPr>
           <p:cNvPr id="52" name="TextBox 51"/>
           <p:cNvSpPr txBox="1"/>
           <p:nvPr/>
         </p:nvSpPr>
         <p:spPr>
           <a:xfrm>
-            <a:off x="7598663" y="3122676"/>
+            <a:off x="7598663" y="3227832"/>
             <a:ext cx="256032" cy="256032"/>
           </a:xfrm>
           <a:prstGeom prst="rect">
@@ -17047,8 +17047,8 @@
         </p:nvCxnSpPr>
         <p:spPr>
           <a:xfrm flipV="1">
-            <a:off x="6949440" y="4361688"/>
-            <a:ext cx="365759" cy="347472"/>
+            <a:off x="6949440" y="3273552"/>
+            <a:ext cx="411479" cy="1344168"/>
           </a:xfrm>
           <a:prstGeom prst="bentConnector3">
             <a:avLst/>
@@ -17083,8 +17083,8 @@
         </p:nvCxnSpPr>
         <p:spPr>
           <a:xfrm flipH="1" flipV="1">
-            <a:off x="8138159" y="4361688"/>
-            <a:ext cx="822960" cy="347472"/>
+            <a:off x="8092440" y="3273552"/>
+            <a:ext cx="868679" cy="1344168"/>
           </a:xfrm>
           <a:prstGeom prst="bentConnector3">
             <a:avLst/>
@@ -17119,7 +17119,7 @@
         </p:nvSpPr>
         <p:spPr>
           <a:xfrm>
-            <a:off x="7004304" y="4407408"/>
+            <a:off x="7027164" y="3817620"/>
             <a:ext cx="256032" cy="256032"/>
           </a:xfrm>
           <a:prstGeom prst="rect">
@@ -17164,7 +17164,7 @@
         </p:nvSpPr>
         <p:spPr>
           <a:xfrm>
-            <a:off x="7004304" y="4389120"/>
+            <a:off x="7027164" y="3799331"/>
             <a:ext cx="256032" cy="256032"/>
           </a:xfrm>
           <a:prstGeom prst="rect">
@@ -17501,7 +17501,7 @@
                   <a:srgbClr val="8B949E"/>
                 </a:solidFill>
               </a:rPr>
-              <a:t>4  query(feature_request)  →  chunks + L2 distances  (internal, per-agent)</a:t>
+              <a:t>4  query(feature_request)  →  chunks + L2 distances  (internal RAG call)</a:t>
             </a:r>
           </a:p>
         </p:txBody>
@@ -17515,85 +17515,6 @@
         <p:spPr>
           <a:xfrm>
             <a:off x="6217920" y="5650992"/>
-            <a:ext cx="201168" cy="141732"/>
-          </a:xfrm>
-          <a:prstGeom prst="rect">
-            <a:avLst/>
-          </a:prstGeom>
-          <a:solidFill>
-            <a:srgbClr val="F0F6FC"/>
-          </a:solidFill>
-          <a:ln w="9525">
-            <a:solidFill>
-              <a:srgbClr val="F0F6FC"/>
-            </a:solidFill>
-          </a:ln>
-        </p:spPr>
-        <p:style>
-          <a:lnRef idx="1">
-            <a:schemeClr val="accent1"/>
-          </a:lnRef>
-          <a:fillRef idx="3">
-            <a:schemeClr val="accent1"/>
-          </a:fillRef>
-          <a:effectRef idx="2">
-            <a:schemeClr val="accent1"/>
-          </a:effectRef>
-          <a:fontRef idx="minor">
-            <a:schemeClr val="lt1"/>
-          </a:fontRef>
-        </p:style>
-        <p:txBody>
-          <a:bodyPr rtlCol="0" anchor="ctr"/>
-          <a:lstStyle/>
-          <a:p>
-            <a:pPr algn="ctr"/>
-          </a:p>
-        </p:txBody>
-      </p:sp>
-      <p:sp>
-        <p:nvSpPr>
-          <p:cNvPr id="66" name="TextBox 65"/>
-          <p:cNvSpPr txBox="1"/>
-          <p:nvPr/>
-        </p:nvSpPr>
-        <p:spPr>
-          <a:xfrm>
-            <a:off x="6464808" y="5641848"/>
-            <a:ext cx="5486400" cy="164592"/>
-          </a:xfrm>
-          <a:prstGeom prst="rect">
-            <a:avLst/>
-          </a:prstGeom>
-          <a:noFill/>
-        </p:spPr>
-        <p:txBody>
-          <a:bodyPr wrap="square">
-            <a:spAutoFit/>
-          </a:bodyPr>
-          <a:lstStyle/>
-          <a:p>
-            <a:pPr algn="l"/>
-            <a:r>
-              <a:rPr sz="750" b="0">
-                <a:solidFill>
-                  <a:srgbClr val="8B949E"/>
-                </a:solidFill>
-              </a:rPr>
-              <a:t>5  encode(text)  →  384-dim float[]  (sentence-transformers, local CPU/GPU)</a:t>
-            </a:r>
-          </a:p>
-        </p:txBody>
-      </p:sp>
-      <p:sp>
-        <p:nvSpPr>
-          <p:cNvPr id="67" name="Rectangle 66"/>
-          <p:cNvSpPr/>
-          <p:nvPr/>
-        </p:nvSpPr>
-        <p:spPr>
-          <a:xfrm>
-            <a:off x="6217920" y="5820156"/>
             <a:ext cx="201168" cy="141732"/>
           </a:xfrm>
           <a:prstGeom prst="rect">
@@ -17632,6 +17553,85 @@
       </p:sp>
       <p:sp>
         <p:nvSpPr>
+          <p:cNvPr id="66" name="TextBox 65"/>
+          <p:cNvSpPr txBox="1"/>
+          <p:nvPr/>
+        </p:nvSpPr>
+        <p:spPr>
+          <a:xfrm>
+            <a:off x="6464808" y="5641848"/>
+            <a:ext cx="5486400" cy="164592"/>
+          </a:xfrm>
+          <a:prstGeom prst="rect">
+            <a:avLst/>
+          </a:prstGeom>
+          <a:noFill/>
+        </p:spPr>
+        <p:txBody>
+          <a:bodyPr wrap="square">
+            <a:spAutoFit/>
+          </a:bodyPr>
+          <a:lstStyle/>
+          <a:p>
+            <a:pPr algn="l"/>
+            <a:r>
+              <a:rPr sz="750" b="0">
+                <a:solidFill>
+                  <a:srgbClr val="8B949E"/>
+                </a:solidFill>
+              </a:rPr>
+              <a:t>5  text chunks / query text  →  384-dim float[]  (RAG → Embedding Model)</a:t>
+            </a:r>
+          </a:p>
+        </p:txBody>
+      </p:sp>
+      <p:sp>
+        <p:nvSpPr>
+          <p:cNvPr id="67" name="Rectangle 66"/>
+          <p:cNvSpPr/>
+          <p:nvPr/>
+        </p:nvSpPr>
+        <p:spPr>
+          <a:xfrm>
+            <a:off x="6217920" y="5820156"/>
+            <a:ext cx="201168" cy="141732"/>
+          </a:xfrm>
+          <a:prstGeom prst="rect">
+            <a:avLst/>
+          </a:prstGeom>
+          <a:solidFill>
+            <a:srgbClr val="58A6FF"/>
+          </a:solidFill>
+          <a:ln w="9525">
+            <a:solidFill>
+              <a:srgbClr val="58A6FF"/>
+            </a:solidFill>
+          </a:ln>
+        </p:spPr>
+        <p:style>
+          <a:lnRef idx="1">
+            <a:schemeClr val="accent1"/>
+          </a:lnRef>
+          <a:fillRef idx="3">
+            <a:schemeClr val="accent1"/>
+          </a:fillRef>
+          <a:effectRef idx="2">
+            <a:schemeClr val="accent1"/>
+          </a:effectRef>
+          <a:fontRef idx="minor">
+            <a:schemeClr val="lt1"/>
+          </a:fontRef>
+        </p:style>
+        <p:txBody>
+          <a:bodyPr rtlCol="0" anchor="ctr"/>
+          <a:lstStyle/>
+          <a:p>
+            <a:pPr algn="ctr"/>
+          </a:p>
+        </p:txBody>
+      </p:sp>
+      <p:sp>
+        <p:nvSpPr>
           <p:cNvPr id="68" name="TextBox 67"/>
           <p:cNvSpPr txBox="1"/>
           <p:nvPr/>
@@ -17659,7 +17659,7 @@
                   <a:srgbClr val="8B949E"/>
                 </a:solidFill>
               </a:rPr>
-              <a:t>6  vector similarity search  →  top-k chunks + L2 dist  (ChromaDB)</a:t>
+              <a:t>6  vectors → store (index) / search (query)  →  top-k chunks + L2 dist  (ChromaDB)</a:t>
             </a:r>
           </a:p>
         </p:txBody>
@@ -17738,7 +17738,7 @@
                   <a:srgbClr val="8B949E"/>
                 </a:solidFill>
               </a:rPr>
-              <a:t>7  indexed at startup  →  text split → embed → stored in .chroma_db/</a:t>
+              <a:t>7  startup indexing: docs+src → chunk → Embedding → vectors → ChromaDB</a:t>
             </a:r>
           </a:p>
         </p:txBody>

</xml_diff>

<commit_message>
Add model-load steps to all three data-flow slides; fix VS Code subtitle
- slide_rag_init_flow: model load strip between Chunker and Embedding Model
  (LOAD SentenceTransformer · ~5-15 s · ~300 MB RAM · once per process)
- slide_rag_query_flow: model load annotations in both routing and query lanes
  (fresh load per ephemeral subprocess · ~40-120 s cold-start for 3 repos)
- slide_vscode_flow: server boxes updated to show "model loaded once at startup";
  RAM annotation bar: 16 procs × ~300 MB ≈ 4.8 GB
- Fix subtitle: clarify VS Code spawns permanent servers; router spawns
  ephemeral peer subprocesses only during routing calls

Co-Authored-By: Claude Sonnet 4.6 <noreply@anthropic.com>
</commit_message>
<xml_diff>
--- a/demo/slides.pptx
+++ b/demo/slides.pptx
@@ -4550,9 +4550,89 @@
           </a:p>
         </p:txBody>
       </p:sp>
+      <p:sp>
+        <p:nvSpPr>
+          <p:cNvPr id="22" name="Rectangle 21"/>
+          <p:cNvSpPr/>
+          <p:nvPr/>
+        </p:nvSpPr>
+        <p:spPr>
+          <a:xfrm>
+            <a:off x="7955279" y="2670048"/>
+            <a:ext cx="3977639" cy="384048"/>
+          </a:xfrm>
+          <a:prstGeom prst="rect">
+            <a:avLst/>
+          </a:prstGeom>
+          <a:solidFill>
+            <a:srgbClr val="0D1422"/>
+          </a:solidFill>
+          <a:ln w="9525">
+            <a:solidFill>
+              <a:srgbClr val="58A6FF"/>
+            </a:solidFill>
+          </a:ln>
+        </p:spPr>
+        <p:style>
+          <a:lnRef idx="1">
+            <a:schemeClr val="accent1"/>
+          </a:lnRef>
+          <a:fillRef idx="3">
+            <a:schemeClr val="accent1"/>
+          </a:fillRef>
+          <a:effectRef idx="2">
+            <a:schemeClr val="accent1"/>
+          </a:effectRef>
+          <a:fontRef idx="minor">
+            <a:schemeClr val="lt1"/>
+          </a:fontRef>
+        </p:style>
+        <p:txBody>
+          <a:bodyPr rtlCol="0" anchor="ctr"/>
+          <a:lstStyle/>
+          <a:p>
+            <a:pPr algn="ctr"/>
+          </a:p>
+        </p:txBody>
+      </p:sp>
+      <p:sp>
+        <p:nvSpPr>
+          <p:cNvPr id="23" name="TextBox 22"/>
+          <p:cNvSpPr txBox="1"/>
+          <p:nvPr/>
+        </p:nvSpPr>
+        <p:spPr>
+          <a:xfrm>
+            <a:off x="8046720" y="2688336"/>
+            <a:ext cx="3794760" cy="329184"/>
+          </a:xfrm>
+          <a:prstGeom prst="rect">
+            <a:avLst/>
+          </a:prstGeom>
+          <a:noFill/>
+        </p:spPr>
+        <p:txBody>
+          <a:bodyPr wrap="square">
+            <a:spAutoFit/>
+          </a:bodyPr>
+          <a:lstStyle/>
+          <a:p>
+            <a:pPr algn="ctr"/>
+            <a:r>
+              <a:rPr sz="750" b="0">
+                <a:solidFill>
+                  <a:srgbClr val="58A6FF"/>
+                </a:solidFill>
+              </a:rPr>
+              <a:t>model loaded fresh per subprocess call  ·  ~5-15 s each  ·  ~300 MB RAM each
+8 calls for 3 repos → ~40-120 s model-load overhead on cold start</a:t>
+            </a:r>
+          </a:p>
+        </p:txBody>
+      </p:sp>
       <p:cxnSp>
         <p:nvCxnSpPr>
-          <p:cNvPr id="22" name="Connector 21"/>
+          <p:cNvPr id="24" name="Connector 23"/>
           <p:cNvCxnSpPr/>
           <p:nvPr/>
         </p:nvCxnSpPr>
@@ -4588,7 +4668,7 @@
       </p:cxnSp>
       <p:sp>
         <p:nvSpPr>
-          <p:cNvPr id="23" name="Rectangle 22"/>
+          <p:cNvPr id="25" name="Rectangle 24"/>
           <p:cNvSpPr/>
           <p:nvPr/>
         </p:nvSpPr>
@@ -4633,7 +4713,7 @@
       </p:sp>
       <p:sp>
         <p:nvSpPr>
-          <p:cNvPr id="24" name="TextBox 23"/>
+          <p:cNvPr id="26" name="TextBox 25"/>
           <p:cNvSpPr txBox="1"/>
           <p:nvPr/>
         </p:nvSpPr>
@@ -4667,7 +4747,7 @@
       </p:sp>
       <p:sp>
         <p:nvSpPr>
-          <p:cNvPr id="25" name="TextBox 24"/>
+          <p:cNvPr id="27" name="TextBox 26"/>
           <p:cNvSpPr txBox="1"/>
           <p:nvPr/>
         </p:nvSpPr>
@@ -4701,7 +4781,7 @@
       </p:sp>
       <p:cxnSp>
         <p:nvCxnSpPr>
-          <p:cNvPr id="26" name="Connector 25"/>
+          <p:cNvPr id="28" name="Connector 27"/>
           <p:cNvCxnSpPr/>
           <p:nvPr/>
         </p:nvCxnSpPr>
@@ -4737,7 +4817,7 @@
       </p:cxnSp>
       <p:sp>
         <p:nvSpPr>
-          <p:cNvPr id="27" name="Rectangle 26"/>
+          <p:cNvPr id="29" name="Rectangle 28"/>
           <p:cNvSpPr/>
           <p:nvPr/>
         </p:nvSpPr>
@@ -4782,7 +4862,7 @@
       </p:sp>
       <p:sp>
         <p:nvSpPr>
-          <p:cNvPr id="28" name="TextBox 27"/>
+          <p:cNvPr id="30" name="TextBox 29"/>
           <p:cNvSpPr txBox="1"/>
           <p:nvPr/>
         </p:nvSpPr>
@@ -4816,7 +4896,7 @@
       </p:sp>
       <p:sp>
         <p:nvSpPr>
-          <p:cNvPr id="29" name="TextBox 28"/>
+          <p:cNvPr id="31" name="TextBox 30"/>
           <p:cNvSpPr txBox="1"/>
           <p:nvPr/>
         </p:nvSpPr>
@@ -4850,7 +4930,7 @@
       </p:sp>
       <p:sp>
         <p:nvSpPr>
-          <p:cNvPr id="30" name="Rectangle 29"/>
+          <p:cNvPr id="32" name="Rectangle 31"/>
           <p:cNvSpPr/>
           <p:nvPr/>
         </p:nvSpPr>
@@ -4895,7 +4975,7 @@
       </p:sp>
       <p:sp>
         <p:nvSpPr>
-          <p:cNvPr id="31" name="TextBox 30"/>
+          <p:cNvPr id="33" name="TextBox 32"/>
           <p:cNvSpPr txBox="1"/>
           <p:nvPr/>
         </p:nvSpPr>
@@ -4929,7 +5009,7 @@
       </p:sp>
       <p:sp>
         <p:nvSpPr>
-          <p:cNvPr id="32" name="TextBox 31"/>
+          <p:cNvPr id="34" name="TextBox 33"/>
           <p:cNvSpPr txBox="1"/>
           <p:nvPr/>
         </p:nvSpPr>
@@ -4963,7 +5043,7 @@
       </p:sp>
       <p:sp>
         <p:nvSpPr>
-          <p:cNvPr id="33" name="Rectangle 32"/>
+          <p:cNvPr id="35" name="Rectangle 34"/>
           <p:cNvSpPr/>
           <p:nvPr/>
         </p:nvSpPr>
@@ -5008,7 +5088,7 @@
       </p:sp>
       <p:sp>
         <p:nvSpPr>
-          <p:cNvPr id="34" name="TextBox 33"/>
+          <p:cNvPr id="36" name="TextBox 35"/>
           <p:cNvSpPr txBox="1"/>
           <p:nvPr/>
         </p:nvSpPr>
@@ -5042,7 +5122,7 @@
       </p:sp>
       <p:sp>
         <p:nvSpPr>
-          <p:cNvPr id="35" name="TextBox 34"/>
+          <p:cNvPr id="37" name="TextBox 36"/>
           <p:cNvSpPr txBox="1"/>
           <p:nvPr/>
         </p:nvSpPr>
@@ -5076,7 +5156,7 @@
       </p:sp>
       <p:sp>
         <p:nvSpPr>
-          <p:cNvPr id="36" name="Rectangle 35"/>
+          <p:cNvPr id="38" name="Rectangle 37"/>
           <p:cNvSpPr/>
           <p:nvPr/>
         </p:nvSpPr>
@@ -5121,7 +5201,7 @@
       </p:sp>
       <p:sp>
         <p:nvSpPr>
-          <p:cNvPr id="37" name="TextBox 36"/>
+          <p:cNvPr id="39" name="TextBox 38"/>
           <p:cNvSpPr txBox="1"/>
           <p:nvPr/>
         </p:nvSpPr>
@@ -5155,7 +5235,7 @@
       </p:sp>
       <p:sp>
         <p:nvSpPr>
-          <p:cNvPr id="38" name="TextBox 37"/>
+          <p:cNvPr id="40" name="TextBox 39"/>
           <p:cNvSpPr txBox="1"/>
           <p:nvPr/>
         </p:nvSpPr>
@@ -5189,7 +5269,7 @@
       </p:sp>
       <p:sp>
         <p:nvSpPr>
-          <p:cNvPr id="39" name="Rectangle 38"/>
+          <p:cNvPr id="41" name="Rectangle 40"/>
           <p:cNvSpPr/>
           <p:nvPr/>
         </p:nvSpPr>
@@ -5234,7 +5314,7 @@
       </p:sp>
       <p:sp>
         <p:nvSpPr>
-          <p:cNvPr id="40" name="TextBox 39"/>
+          <p:cNvPr id="42" name="TextBox 41"/>
           <p:cNvSpPr txBox="1"/>
           <p:nvPr/>
         </p:nvSpPr>
@@ -5268,7 +5348,7 @@
       </p:sp>
       <p:sp>
         <p:nvSpPr>
-          <p:cNvPr id="41" name="TextBox 40"/>
+          <p:cNvPr id="43" name="TextBox 42"/>
           <p:cNvSpPr txBox="1"/>
           <p:nvPr/>
         </p:nvSpPr>
@@ -5305,7 +5385,7 @@
       </p:sp>
       <p:sp>
         <p:nvSpPr>
-          <p:cNvPr id="42" name="Rectangle 41"/>
+          <p:cNvPr id="44" name="Rectangle 43"/>
           <p:cNvSpPr/>
           <p:nvPr/>
         </p:nvSpPr>
@@ -5350,7 +5430,7 @@
       </p:sp>
       <p:sp>
         <p:nvSpPr>
-          <p:cNvPr id="43" name="TextBox 42"/>
+          <p:cNvPr id="45" name="TextBox 44"/>
           <p:cNvSpPr txBox="1"/>
           <p:nvPr/>
         </p:nvSpPr>
@@ -5384,7 +5464,7 @@
       </p:sp>
       <p:sp>
         <p:nvSpPr>
-          <p:cNvPr id="44" name="TextBox 43"/>
+          <p:cNvPr id="46" name="TextBox 45"/>
           <p:cNvSpPr txBox="1"/>
           <p:nvPr/>
         </p:nvSpPr>
@@ -5419,7 +5499,7 @@
       </p:sp>
       <p:sp>
         <p:nvSpPr>
-          <p:cNvPr id="45" name="Rectangle 44"/>
+          <p:cNvPr id="47" name="Rectangle 46"/>
           <p:cNvSpPr/>
           <p:nvPr/>
         </p:nvSpPr>
@@ -5464,7 +5544,7 @@
       </p:sp>
       <p:sp>
         <p:nvSpPr>
-          <p:cNvPr id="46" name="TextBox 45"/>
+          <p:cNvPr id="48" name="TextBox 47"/>
           <p:cNvSpPr txBox="1"/>
           <p:nvPr/>
         </p:nvSpPr>
@@ -5498,7 +5578,7 @@
       </p:sp>
       <p:sp>
         <p:nvSpPr>
-          <p:cNvPr id="47" name="TextBox 46"/>
+          <p:cNvPr id="49" name="TextBox 48"/>
           <p:cNvSpPr txBox="1"/>
           <p:nvPr/>
         </p:nvSpPr>
@@ -5530,9 +5610,88 @@
           </a:p>
         </p:txBody>
       </p:sp>
+      <p:sp>
+        <p:nvSpPr>
+          <p:cNvPr id="50" name="Rectangle 49"/>
+          <p:cNvSpPr/>
+          <p:nvPr/>
+        </p:nvSpPr>
+        <p:spPr>
+          <a:xfrm>
+            <a:off x="256032" y="4261104"/>
+            <a:ext cx="6492240" cy="192024"/>
+          </a:xfrm>
+          <a:prstGeom prst="rect">
+            <a:avLst/>
+          </a:prstGeom>
+          <a:solidFill>
+            <a:srgbClr val="0D1422"/>
+          </a:solidFill>
+          <a:ln w="9525">
+            <a:solidFill>
+              <a:srgbClr val="58A6FF"/>
+            </a:solidFill>
+          </a:ln>
+        </p:spPr>
+        <p:style>
+          <a:lnRef idx="1">
+            <a:schemeClr val="accent1"/>
+          </a:lnRef>
+          <a:fillRef idx="3">
+            <a:schemeClr val="accent1"/>
+          </a:fillRef>
+          <a:effectRef idx="2">
+            <a:schemeClr val="accent1"/>
+          </a:effectRef>
+          <a:fontRef idx="minor">
+            <a:schemeClr val="lt1"/>
+          </a:fontRef>
+        </p:style>
+        <p:txBody>
+          <a:bodyPr rtlCol="0" anchor="ctr"/>
+          <a:lstStyle/>
+          <a:p>
+            <a:pPr algn="ctr"/>
+          </a:p>
+        </p:txBody>
+      </p:sp>
+      <p:sp>
+        <p:nvSpPr>
+          <p:cNvPr id="51" name="TextBox 50"/>
+          <p:cNvSpPr txBox="1"/>
+          <p:nvPr/>
+        </p:nvSpPr>
+        <p:spPr>
+          <a:xfrm>
+            <a:off x="347472" y="4270248"/>
+            <a:ext cx="6309360" cy="155448"/>
+          </a:xfrm>
+          <a:prstGeom prst="rect">
+            <a:avLst/>
+          </a:prstGeom>
+          <a:noFill/>
+        </p:spPr>
+        <p:txBody>
+          <a:bodyPr wrap="square">
+            <a:spAutoFit/>
+          </a:bodyPr>
+          <a:lstStyle/>
+          <a:p>
+            <a:pPr algn="ctr"/>
+            <a:r>
+              <a:rPr sz="700" b="0">
+                <a:solidFill>
+                  <a:srgbClr val="58A6FF"/>
+                </a:solidFill>
+              </a:rPr>
+              <a:t>each ephemeral mcp_server subprocess loads all-MiniLM-L6-v2 fresh  ·  ~5-15 s per subprocess  ·  ~300 MB RAM per process</a:t>
+            </a:r>
+          </a:p>
+        </p:txBody>
+      </p:sp>
       <p:cxnSp>
         <p:nvCxnSpPr>
-          <p:cNvPr id="48" name="Connector 47"/>
+          <p:cNvPr id="52" name="Connector 51"/>
           <p:cNvCxnSpPr/>
           <p:nvPr/>
         </p:nvCxnSpPr>
@@ -5568,7 +5727,7 @@
       </p:cxnSp>
       <p:sp>
         <p:nvSpPr>
-          <p:cNvPr id="49" name="Rectangle 48"/>
+          <p:cNvPr id="53" name="Rectangle 52"/>
           <p:cNvSpPr/>
           <p:nvPr/>
         </p:nvSpPr>
@@ -5613,7 +5772,7 @@
       </p:sp>
       <p:sp>
         <p:nvSpPr>
-          <p:cNvPr id="50" name="TextBox 49"/>
+          <p:cNvPr id="54" name="TextBox 53"/>
           <p:cNvSpPr txBox="1"/>
           <p:nvPr/>
         </p:nvSpPr>
@@ -5647,7 +5806,7 @@
       </p:sp>
       <p:sp>
         <p:nvSpPr>
-          <p:cNvPr id="51" name="TextBox 50"/>
+          <p:cNvPr id="55" name="TextBox 54"/>
           <p:cNvSpPr txBox="1"/>
           <p:nvPr/>
         </p:nvSpPr>
@@ -5681,7 +5840,7 @@
       </p:sp>
       <p:cxnSp>
         <p:nvCxnSpPr>
-          <p:cNvPr id="52" name="Connector 51"/>
+          <p:cNvPr id="56" name="Connector 55"/>
           <p:cNvCxnSpPr/>
           <p:nvPr/>
         </p:nvCxnSpPr>
@@ -5717,7 +5876,7 @@
       </p:cxnSp>
       <p:sp>
         <p:nvSpPr>
-          <p:cNvPr id="53" name="Rectangle 52"/>
+          <p:cNvPr id="57" name="Rectangle 56"/>
           <p:cNvSpPr/>
           <p:nvPr/>
         </p:nvSpPr>
@@ -5762,7 +5921,7 @@
       </p:sp>
       <p:sp>
         <p:nvSpPr>
-          <p:cNvPr id="54" name="TextBox 53"/>
+          <p:cNvPr id="58" name="TextBox 57"/>
           <p:cNvSpPr txBox="1"/>
           <p:nvPr/>
         </p:nvSpPr>
@@ -5796,7 +5955,7 @@
       </p:sp>
       <p:sp>
         <p:nvSpPr>
-          <p:cNvPr id="55" name="TextBox 54"/>
+          <p:cNvPr id="59" name="TextBox 58"/>
           <p:cNvSpPr txBox="1"/>
           <p:nvPr/>
         </p:nvSpPr>
@@ -5830,7 +5989,7 @@
       </p:sp>
       <p:cxnSp>
         <p:nvCxnSpPr>
-          <p:cNvPr id="56" name="Connector 55"/>
+          <p:cNvPr id="60" name="Connector 59"/>
           <p:cNvCxnSpPr/>
           <p:nvPr/>
         </p:nvCxnSpPr>
@@ -5866,7 +6025,7 @@
       </p:cxnSp>
       <p:sp>
         <p:nvSpPr>
-          <p:cNvPr id="57" name="Rectangle 56"/>
+          <p:cNvPr id="61" name="Rectangle 60"/>
           <p:cNvSpPr/>
           <p:nvPr/>
         </p:nvSpPr>
@@ -5911,7 +6070,7 @@
       </p:sp>
       <p:sp>
         <p:nvSpPr>
-          <p:cNvPr id="58" name="TextBox 57"/>
+          <p:cNvPr id="62" name="TextBox 61"/>
           <p:cNvSpPr txBox="1"/>
           <p:nvPr/>
         </p:nvSpPr>
@@ -5945,7 +6104,7 @@
       </p:sp>
       <p:sp>
         <p:nvSpPr>
-          <p:cNvPr id="59" name="TextBox 58"/>
+          <p:cNvPr id="63" name="TextBox 62"/>
           <p:cNvSpPr txBox="1"/>
           <p:nvPr/>
         </p:nvSpPr>
@@ -5979,7 +6138,7 @@
       </p:sp>
       <p:cxnSp>
         <p:nvCxnSpPr>
-          <p:cNvPr id="60" name="Connector 59"/>
+          <p:cNvPr id="64" name="Connector 63"/>
           <p:cNvCxnSpPr/>
           <p:nvPr/>
         </p:nvCxnSpPr>
@@ -6015,7 +6174,7 @@
       </p:cxnSp>
       <p:sp>
         <p:nvSpPr>
-          <p:cNvPr id="61" name="Rectangle 60"/>
+          <p:cNvPr id="65" name="Rectangle 64"/>
           <p:cNvSpPr/>
           <p:nvPr/>
         </p:nvSpPr>
@@ -6060,7 +6219,7 @@
       </p:sp>
       <p:sp>
         <p:nvSpPr>
-          <p:cNvPr id="62" name="TextBox 61"/>
+          <p:cNvPr id="66" name="TextBox 65"/>
           <p:cNvSpPr txBox="1"/>
           <p:nvPr/>
         </p:nvSpPr>
@@ -6094,7 +6253,7 @@
       </p:sp>
       <p:sp>
         <p:nvSpPr>
-          <p:cNvPr id="63" name="TextBox 62"/>
+          <p:cNvPr id="67" name="TextBox 66"/>
           <p:cNvSpPr txBox="1"/>
           <p:nvPr/>
         </p:nvSpPr>
@@ -6128,7 +6287,7 @@
       </p:sp>
       <p:cxnSp>
         <p:nvCxnSpPr>
-          <p:cNvPr id="64" name="Connector 63"/>
+          <p:cNvPr id="68" name="Connector 67"/>
           <p:cNvCxnSpPr/>
           <p:nvPr/>
         </p:nvCxnSpPr>
@@ -6164,7 +6323,7 @@
       </p:cxnSp>
       <p:sp>
         <p:nvSpPr>
-          <p:cNvPr id="65" name="TextBox 64"/>
+          <p:cNvPr id="69" name="TextBox 68"/>
           <p:cNvSpPr txBox="1"/>
           <p:nvPr/>
         </p:nvSpPr>
@@ -6198,7 +6357,7 @@
       </p:sp>
       <p:cxnSp>
         <p:nvCxnSpPr>
-          <p:cNvPr id="66" name="Connector 65"/>
+          <p:cNvPr id="70" name="Connector 69"/>
           <p:cNvCxnSpPr/>
           <p:nvPr/>
         </p:nvCxnSpPr>
@@ -6234,7 +6393,7 @@
       </p:cxnSp>
       <p:sp>
         <p:nvSpPr>
-          <p:cNvPr id="67" name="TextBox 66"/>
+          <p:cNvPr id="71" name="TextBox 70"/>
           <p:cNvSpPr txBox="1"/>
           <p:nvPr/>
         </p:nvSpPr>
@@ -6355,7 +6514,7 @@
                   <a:srgbClr val="F0F6FC"/>
                 </a:solidFill>
               </a:rPr>
-              <a:t>Permanent MCP Servers  ·  Streaming stdio Pipes  ·  Ephemeral Routing Subprocesses</a:t>
+              <a:t>VS Code spawns 4 permanent servers per window  ·  router spawns ephemeral peer subprocesses only during routing calls</a:t>
             </a:r>
           </a:p>
         </p:txBody>
@@ -6583,7 +6742,7 @@
                   <a:srgbClr val="8B949E"/>
                 </a:solidFill>
               </a:rPr>
-              <a:t>permanent · stdio pipe</a:t>
+              <a:t>permanent · model loaded once at startup</a:t>
             </a:r>
           </a:p>
         </p:txBody>
@@ -6696,7 +6855,7 @@
                   <a:srgbClr val="8B949E"/>
                 </a:solidFill>
               </a:rPr>
-              <a:t>permanent · stdio pipe</a:t>
+              <a:t>permanent · model loaded once at startup</a:t>
             </a:r>
           </a:p>
         </p:txBody>
@@ -6809,7 +6968,7 @@
                   <a:srgbClr val="8B949E"/>
                 </a:solidFill>
               </a:rPr>
-              <a:t>permanent · stdio pipe</a:t>
+              <a:t>permanent · model loaded once at startup</a:t>
             </a:r>
           </a:p>
         </p:txBody>
@@ -6922,7 +7081,7 @@
                   <a:srgbClr val="8B949E"/>
                 </a:solidFill>
               </a:rPr>
-              <a:t>permanent · stdio pipe</a:t>
+              <a:t>permanent · model loaded once at startup</a:t>
             </a:r>
           </a:p>
         </p:txBody>
@@ -7115,7 +7274,7 @@
                   <a:srgbClr val="8B949E"/>
                 </a:solidFill>
               </a:rPr>
-              <a:t>permanent · stdio pipe</a:t>
+              <a:t>permanent · model loaded once at startup</a:t>
             </a:r>
           </a:p>
         </p:txBody>
@@ -7228,7 +7387,7 @@
                   <a:srgbClr val="8B949E"/>
                 </a:solidFill>
               </a:rPr>
-              <a:t>permanent · stdio pipe</a:t>
+              <a:t>permanent · model loaded once at startup</a:t>
             </a:r>
           </a:p>
         </p:txBody>
@@ -7341,7 +7500,7 @@
                   <a:srgbClr val="8B949E"/>
                 </a:solidFill>
               </a:rPr>
-              <a:t>permanent · stdio pipe</a:t>
+              <a:t>permanent · model loaded once at startup</a:t>
             </a:r>
           </a:p>
         </p:txBody>
@@ -7454,7 +7613,7 @@
                   <a:srgbClr val="8B949E"/>
                 </a:solidFill>
               </a:rPr>
-              <a:t>permanent · stdio pipe</a:t>
+              <a:t>permanent · model loaded once at startup</a:t>
             </a:r>
           </a:p>
         </p:txBody>
@@ -7647,7 +7806,7 @@
                   <a:srgbClr val="8B949E"/>
                 </a:solidFill>
               </a:rPr>
-              <a:t>permanent · stdio pipe</a:t>
+              <a:t>permanent · model loaded once at startup</a:t>
             </a:r>
           </a:p>
         </p:txBody>
@@ -7760,7 +7919,7 @@
                   <a:srgbClr val="8B949E"/>
                 </a:solidFill>
               </a:rPr>
-              <a:t>permanent · stdio pipe</a:t>
+              <a:t>permanent · model loaded once at startup</a:t>
             </a:r>
           </a:p>
         </p:txBody>
@@ -7873,7 +8032,7 @@
                   <a:srgbClr val="8B949E"/>
                 </a:solidFill>
               </a:rPr>
-              <a:t>permanent · stdio pipe</a:t>
+              <a:t>permanent · model loaded once at startup</a:t>
             </a:r>
           </a:p>
         </p:txBody>
@@ -7986,7 +8145,7 @@
                   <a:srgbClr val="8B949E"/>
                 </a:solidFill>
               </a:rPr>
-              <a:t>permanent · stdio pipe</a:t>
+              <a:t>permanent · model loaded once at startup</a:t>
             </a:r>
           </a:p>
         </p:txBody>
@@ -8179,7 +8338,7 @@
                   <a:srgbClr val="8B949E"/>
                 </a:solidFill>
               </a:rPr>
-              <a:t>permanent · stdio pipe</a:t>
+              <a:t>permanent · model loaded once at startup</a:t>
             </a:r>
           </a:p>
         </p:txBody>
@@ -8292,7 +8451,7 @@
                   <a:srgbClr val="8B949E"/>
                 </a:solidFill>
               </a:rPr>
-              <a:t>permanent · stdio pipe</a:t>
+              <a:t>permanent · model loaded once at startup</a:t>
             </a:r>
           </a:p>
         </p:txBody>
@@ -8405,7 +8564,7 @@
                   <a:srgbClr val="8B949E"/>
                 </a:solidFill>
               </a:rPr>
-              <a:t>permanent · stdio pipe</a:t>
+              <a:t>permanent · model loaded once at startup</a:t>
             </a:r>
           </a:p>
         </p:txBody>
@@ -8518,7 +8677,7 @@
                   <a:srgbClr val="8B949E"/>
                 </a:solidFill>
               </a:rPr>
-              <a:t>permanent · stdio pipe</a:t>
+              <a:t>permanent · model loaded once at startup</a:t>
             </a:r>
           </a:p>
         </p:txBody>
@@ -8526,6 +8685,85 @@
       <p:sp>
         <p:nvSpPr>
           <p:cNvPr id="61" name="Rectangle 60"/>
+          <p:cNvSpPr/>
+          <p:nvPr/>
+        </p:nvSpPr>
+        <p:spPr>
+          <a:xfrm>
+            <a:off x="201168" y="4544568"/>
+            <a:ext cx="11887200" cy="155448"/>
+          </a:xfrm>
+          <a:prstGeom prst="rect">
+            <a:avLst/>
+          </a:prstGeom>
+          <a:solidFill>
+            <a:srgbClr val="0D1422"/>
+          </a:solidFill>
+          <a:ln w="9525">
+            <a:solidFill>
+              <a:srgbClr val="58A6FF"/>
+            </a:solidFill>
+          </a:ln>
+        </p:spPr>
+        <p:style>
+          <a:lnRef idx="1">
+            <a:schemeClr val="accent1"/>
+          </a:lnRef>
+          <a:fillRef idx="3">
+            <a:schemeClr val="accent1"/>
+          </a:fillRef>
+          <a:effectRef idx="2">
+            <a:schemeClr val="accent1"/>
+          </a:effectRef>
+          <a:fontRef idx="minor">
+            <a:schemeClr val="lt1"/>
+          </a:fontRef>
+        </p:style>
+        <p:txBody>
+          <a:bodyPr rtlCol="0" anchor="ctr"/>
+          <a:lstStyle/>
+          <a:p>
+            <a:pPr algn="ctr"/>
+          </a:p>
+        </p:txBody>
+      </p:sp>
+      <p:sp>
+        <p:nvSpPr>
+          <p:cNvPr id="62" name="TextBox 61"/>
+          <p:cNvSpPr txBox="1"/>
+          <p:nvPr/>
+        </p:nvSpPr>
+        <p:spPr>
+          <a:xfrm>
+            <a:off x="320040" y="4553712"/>
+            <a:ext cx="11658600" cy="128016"/>
+          </a:xfrm>
+          <a:prstGeom prst="rect">
+            <a:avLst/>
+          </a:prstGeom>
+          <a:noFill/>
+        </p:spPr>
+        <p:txBody>
+          <a:bodyPr wrap="square">
+            <a:spAutoFit/>
+          </a:bodyPr>
+          <a:lstStyle/>
+          <a:p>
+            <a:pPr algn="ctr"/>
+            <a:r>
+              <a:rPr sz="700" b="0">
+                <a:solidFill>
+                  <a:srgbClr val="58A6FF"/>
+                </a:solidFill>
+              </a:rPr>
+              <a:t>all-MiniLM-L6-v2 loaded ONCE at VS Code startup per process  ·  model stays in RAM for ALL Copilot queries  ·  16 procs × ~300 MB ≈ 4.8 GB total</a:t>
+            </a:r>
+          </a:p>
+        </p:txBody>
+      </p:sp>
+      <p:sp>
+        <p:nvSpPr>
+          <p:cNvPr id="63" name="Rectangle 62"/>
           <p:cNvSpPr/>
           <p:nvPr/>
         </p:nvSpPr>
@@ -8570,7 +8808,7 @@
       </p:sp>
       <p:sp>
         <p:nvSpPr>
-          <p:cNvPr id="62" name="TextBox 61"/>
+          <p:cNvPr id="64" name="TextBox 63"/>
           <p:cNvSpPr txBox="1"/>
           <p:nvPr/>
         </p:nvSpPr>
@@ -8604,7 +8842,7 @@
       </p:sp>
       <p:sp>
         <p:nvSpPr>
-          <p:cNvPr id="63" name="Rectangle 62"/>
+          <p:cNvPr id="65" name="Rectangle 64"/>
           <p:cNvSpPr/>
           <p:nvPr/>
         </p:nvSpPr>
@@ -8649,7 +8887,7 @@
       </p:sp>
       <p:sp>
         <p:nvSpPr>
-          <p:cNvPr id="64" name="TextBox 63"/>
+          <p:cNvPr id="66" name="TextBox 65"/>
           <p:cNvSpPr txBox="1"/>
           <p:nvPr/>
         </p:nvSpPr>
@@ -8683,7 +8921,7 @@
       </p:sp>
       <p:sp>
         <p:nvSpPr>
-          <p:cNvPr id="65" name="Rectangle 64"/>
+          <p:cNvPr id="67" name="Rectangle 66"/>
           <p:cNvSpPr/>
           <p:nvPr/>
         </p:nvSpPr>
@@ -8728,7 +8966,7 @@
       </p:sp>
       <p:sp>
         <p:nvSpPr>
-          <p:cNvPr id="66" name="TextBox 65"/>
+          <p:cNvPr id="68" name="TextBox 67"/>
           <p:cNvSpPr txBox="1"/>
           <p:nvPr/>
         </p:nvSpPr>
@@ -8763,7 +9001,7 @@
       </p:sp>
       <p:sp>
         <p:nvSpPr>
-          <p:cNvPr id="67" name="Rectangle 66"/>
+          <p:cNvPr id="69" name="Rectangle 68"/>
           <p:cNvSpPr/>
           <p:nvPr/>
         </p:nvSpPr>
@@ -8808,7 +9046,7 @@
       </p:sp>
       <p:sp>
         <p:nvSpPr>
-          <p:cNvPr id="68" name="TextBox 67"/>
+          <p:cNvPr id="70" name="TextBox 69"/>
           <p:cNvSpPr txBox="1"/>
           <p:nvPr/>
         </p:nvSpPr>
@@ -8843,7 +9081,7 @@
       </p:sp>
       <p:sp>
         <p:nvSpPr>
-          <p:cNvPr id="69" name="Rectangle 68"/>
+          <p:cNvPr id="71" name="Rectangle 70"/>
           <p:cNvSpPr/>
           <p:nvPr/>
         </p:nvSpPr>
@@ -8888,7 +9126,7 @@
       </p:sp>
       <p:sp>
         <p:nvSpPr>
-          <p:cNvPr id="70" name="TextBox 69"/>
+          <p:cNvPr id="72" name="TextBox 71"/>
           <p:cNvSpPr txBox="1"/>
           <p:nvPr/>
         </p:nvSpPr>
@@ -8923,7 +9161,7 @@
       </p:sp>
       <p:sp>
         <p:nvSpPr>
-          <p:cNvPr id="71" name="Rectangle 70"/>
+          <p:cNvPr id="73" name="Rectangle 72"/>
           <p:cNvSpPr/>
           <p:nvPr/>
         </p:nvSpPr>
@@ -8968,7 +9206,7 @@
       </p:sp>
       <p:sp>
         <p:nvSpPr>
-          <p:cNvPr id="72" name="TextBox 71"/>
+          <p:cNvPr id="74" name="TextBox 73"/>
           <p:cNvSpPr txBox="1"/>
           <p:nvPr/>
         </p:nvSpPr>
@@ -9003,7 +9241,7 @@
       </p:sp>
       <p:sp>
         <p:nvSpPr>
-          <p:cNvPr id="73" name="Rectangle 72"/>
+          <p:cNvPr id="75" name="Rectangle 74"/>
           <p:cNvSpPr/>
           <p:nvPr/>
         </p:nvSpPr>
@@ -9048,7 +9286,7 @@
       </p:sp>
       <p:sp>
         <p:nvSpPr>
-          <p:cNvPr id="74" name="TextBox 73"/>
+          <p:cNvPr id="76" name="TextBox 75"/>
           <p:cNvSpPr txBox="1"/>
           <p:nvPr/>
         </p:nvSpPr>
@@ -9083,7 +9321,7 @@
       </p:sp>
       <p:cxnSp>
         <p:nvCxnSpPr>
-          <p:cNvPr id="75" name="Connector 74"/>
+          <p:cNvPr id="77" name="Connector 76"/>
           <p:cNvCxnSpPr/>
           <p:nvPr/>
         </p:nvCxnSpPr>
@@ -9119,7 +9357,7 @@
       </p:cxnSp>
       <p:sp>
         <p:nvSpPr>
-          <p:cNvPr id="76" name="TextBox 75"/>
+          <p:cNvPr id="78" name="TextBox 77"/>
           <p:cNvSpPr txBox="1"/>
           <p:nvPr/>
         </p:nvSpPr>
@@ -9154,7 +9392,7 @@
       </p:sp>
       <p:cxnSp>
         <p:nvCxnSpPr>
-          <p:cNvPr id="77" name="Connector 76"/>
+          <p:cNvPr id="79" name="Connector 78"/>
           <p:cNvCxnSpPr/>
           <p:nvPr/>
         </p:nvCxnSpPr>
@@ -9190,7 +9428,7 @@
       </p:cxnSp>
       <p:sp>
         <p:nvSpPr>
-          <p:cNvPr id="78" name="TextBox 77"/>
+          <p:cNvPr id="80" name="TextBox 79"/>
           <p:cNvSpPr txBox="1"/>
           <p:nvPr/>
         </p:nvSpPr>
@@ -9225,7 +9463,7 @@
       </p:sp>
       <p:cxnSp>
         <p:nvCxnSpPr>
-          <p:cNvPr id="79" name="Connector 78"/>
+          <p:cNvPr id="81" name="Connector 80"/>
           <p:cNvCxnSpPr/>
           <p:nvPr/>
         </p:nvCxnSpPr>
@@ -9261,7 +9499,7 @@
       </p:cxnSp>
       <p:sp>
         <p:nvSpPr>
-          <p:cNvPr id="80" name="TextBox 79"/>
+          <p:cNvPr id="82" name="TextBox 81"/>
           <p:cNvSpPr txBox="1"/>
           <p:nvPr/>
         </p:nvSpPr>
@@ -9296,7 +9534,7 @@
       </p:sp>
       <p:cxnSp>
         <p:nvCxnSpPr>
-          <p:cNvPr id="81" name="Connector 80"/>
+          <p:cNvPr id="83" name="Connector 82"/>
           <p:cNvCxnSpPr/>
           <p:nvPr/>
         </p:nvCxnSpPr>
@@ -9332,7 +9570,7 @@
       </p:cxnSp>
       <p:sp>
         <p:nvSpPr>
-          <p:cNvPr id="82" name="TextBox 81"/>
+          <p:cNvPr id="84" name="TextBox 83"/>
           <p:cNvSpPr txBox="1"/>
           <p:nvPr/>
         </p:nvSpPr>
@@ -9367,7 +9605,7 @@
       </p:sp>
       <p:sp>
         <p:nvSpPr>
-          <p:cNvPr id="83" name="TextBox 82"/>
+          <p:cNvPr id="85" name="TextBox 84"/>
           <p:cNvSpPr txBox="1"/>
           <p:nvPr/>
         </p:nvSpPr>
@@ -21398,6 +21636,85 @@
         </p:nvSpPr>
         <p:spPr>
           <a:xfrm>
+            <a:off x="3703320" y="4233672"/>
+            <a:ext cx="4800600" cy="274320"/>
+          </a:xfrm>
+          <a:prstGeom prst="rect">
+            <a:avLst/>
+          </a:prstGeom>
+          <a:solidFill>
+            <a:srgbClr val="0D182A"/>
+          </a:solidFill>
+          <a:ln w="9525">
+            <a:solidFill>
+              <a:srgbClr val="58A6FF"/>
+            </a:solidFill>
+          </a:ln>
+        </p:spPr>
+        <p:style>
+          <a:lnRef idx="1">
+            <a:schemeClr val="accent1"/>
+          </a:lnRef>
+          <a:fillRef idx="3">
+            <a:schemeClr val="accent1"/>
+          </a:fillRef>
+          <a:effectRef idx="2">
+            <a:schemeClr val="accent1"/>
+          </a:effectRef>
+          <a:fontRef idx="minor">
+            <a:schemeClr val="lt1"/>
+          </a:fontRef>
+        </p:style>
+        <p:txBody>
+          <a:bodyPr rtlCol="0" anchor="ctr"/>
+          <a:lstStyle/>
+          <a:p>
+            <a:pPr algn="ctr"/>
+          </a:p>
+        </p:txBody>
+      </p:sp>
+      <p:sp>
+        <p:nvSpPr>
+          <p:cNvPr id="21" name="TextBox 20"/>
+          <p:cNvSpPr txBox="1"/>
+          <p:nvPr/>
+        </p:nvSpPr>
+        <p:spPr>
+          <a:xfrm>
+            <a:off x="3794759" y="4251960"/>
+            <a:ext cx="4617720" cy="201168"/>
+          </a:xfrm>
+          <a:prstGeom prst="rect">
+            <a:avLst/>
+          </a:prstGeom>
+          <a:noFill/>
+        </p:spPr>
+        <p:txBody>
+          <a:bodyPr wrap="square">
+            <a:spAutoFit/>
+          </a:bodyPr>
+          <a:lstStyle/>
+          <a:p>
+            <a:pPr algn="ctr"/>
+            <a:r>
+              <a:rPr sz="800" b="0">
+                <a:solidFill>
+                  <a:srgbClr val="58A6FF"/>
+                </a:solidFill>
+              </a:rPr>
+              <a:t>LOAD  SentenceTransformer('all-MiniLM-L6-v2')  ·  ~5-15 s  ·  ~300 MB RAM  ·  paid once at mcp_server process start, before any encoding</a:t>
+            </a:r>
+          </a:p>
+        </p:txBody>
+      </p:sp>
+      <p:sp>
+        <p:nvSpPr>
+          <p:cNvPr id="22" name="Rectangle 21"/>
+          <p:cNvSpPr/>
+          <p:nvPr/>
+        </p:nvSpPr>
+        <p:spPr>
+          <a:xfrm>
             <a:off x="3703320" y="4572000"/>
             <a:ext cx="4800600" cy="777240"/>
           </a:xfrm>
@@ -21437,7 +21754,7 @@
       </p:sp>
       <p:sp>
         <p:nvSpPr>
-          <p:cNvPr id="21" name="TextBox 20"/>
+          <p:cNvPr id="23" name="TextBox 22"/>
           <p:cNvSpPr txBox="1"/>
           <p:nvPr/>
         </p:nvSpPr>
@@ -21471,7 +21788,7 @@
       </p:sp>
       <p:sp>
         <p:nvSpPr>
-          <p:cNvPr id="22" name="TextBox 21"/>
+          <p:cNvPr id="24" name="TextBox 23"/>
           <p:cNvSpPr txBox="1"/>
           <p:nvPr/>
         </p:nvSpPr>
@@ -21506,7 +21823,7 @@
       </p:sp>
       <p:sp>
         <p:nvSpPr>
-          <p:cNvPr id="23" name="Rectangle 22"/>
+          <p:cNvPr id="25" name="Rectangle 24"/>
           <p:cNvSpPr/>
           <p:nvPr/>
         </p:nvSpPr>
@@ -21551,7 +21868,7 @@
       </p:sp>
       <p:sp>
         <p:nvSpPr>
-          <p:cNvPr id="24" name="TextBox 23"/>
+          <p:cNvPr id="26" name="TextBox 25"/>
           <p:cNvSpPr txBox="1"/>
           <p:nvPr/>
         </p:nvSpPr>
@@ -21585,7 +21902,7 @@
       </p:sp>
       <p:sp>
         <p:nvSpPr>
-          <p:cNvPr id="25" name="TextBox 24"/>
+          <p:cNvPr id="27" name="TextBox 26"/>
           <p:cNvSpPr txBox="1"/>
           <p:nvPr/>
         </p:nvSpPr>
@@ -21620,7 +21937,7 @@
       </p:sp>
       <p:cxnSp>
         <p:nvCxnSpPr>
-          <p:cNvPr id="26" name="Connector 25"/>
+          <p:cNvPr id="28" name="Connector 27"/>
           <p:cNvCxnSpPr/>
           <p:nvPr/>
         </p:nvCxnSpPr>
@@ -21656,7 +21973,7 @@
       </p:cxnSp>
       <p:sp>
         <p:nvSpPr>
-          <p:cNvPr id="27" name="Rectangle 26"/>
+          <p:cNvPr id="29" name="Rectangle 28"/>
           <p:cNvSpPr/>
           <p:nvPr/>
         </p:nvSpPr>
@@ -21701,7 +22018,7 @@
       </p:sp>
       <p:sp>
         <p:nvSpPr>
-          <p:cNvPr id="28" name="TextBox 27"/>
+          <p:cNvPr id="30" name="TextBox 29"/>
           <p:cNvSpPr txBox="1"/>
           <p:nvPr/>
         </p:nvSpPr>
@@ -21735,7 +22052,7 @@
       </p:sp>
       <p:sp>
         <p:nvSpPr>
-          <p:cNvPr id="29" name="TextBox 28"/>
+          <p:cNvPr id="31" name="TextBox 30"/>
           <p:cNvSpPr txBox="1"/>
           <p:nvPr/>
         </p:nvSpPr>
@@ -21769,7 +22086,7 @@
       </p:sp>
       <p:cxnSp>
         <p:nvCxnSpPr>
-          <p:cNvPr id="30" name="Connector 29"/>
+          <p:cNvPr id="32" name="Connector 31"/>
           <p:cNvCxnSpPr/>
           <p:nvPr/>
         </p:nvCxnSpPr>
@@ -21805,7 +22122,7 @@
       </p:cxnSp>
       <p:sp>
         <p:nvSpPr>
-          <p:cNvPr id="31" name="Rectangle 30"/>
+          <p:cNvPr id="33" name="Rectangle 32"/>
           <p:cNvSpPr/>
           <p:nvPr/>
         </p:nvSpPr>
@@ -21850,7 +22167,7 @@
       </p:sp>
       <p:sp>
         <p:nvSpPr>
-          <p:cNvPr id="32" name="TextBox 31"/>
+          <p:cNvPr id="34" name="TextBox 33"/>
           <p:cNvSpPr txBox="1"/>
           <p:nvPr/>
         </p:nvSpPr>
@@ -21884,7 +22201,7 @@
       </p:sp>
       <p:sp>
         <p:nvSpPr>
-          <p:cNvPr id="33" name="TextBox 32"/>
+          <p:cNvPr id="35" name="TextBox 34"/>
           <p:cNvSpPr txBox="1"/>
           <p:nvPr/>
         </p:nvSpPr>
@@ -21918,7 +22235,7 @@
       </p:sp>
       <p:cxnSp>
         <p:nvCxnSpPr>
-          <p:cNvPr id="34" name="Connector 33"/>
+          <p:cNvPr id="36" name="Connector 35"/>
           <p:cNvCxnSpPr/>
           <p:nvPr/>
         </p:nvCxnSpPr>
@@ -21954,7 +22271,7 @@
       </p:cxnSp>
       <p:sp>
         <p:nvSpPr>
-          <p:cNvPr id="35" name="TextBox 34"/>
+          <p:cNvPr id="37" name="TextBox 36"/>
           <p:cNvSpPr txBox="1"/>
           <p:nvPr/>
         </p:nvSpPr>
@@ -21988,7 +22305,7 @@
       </p:sp>
       <p:cxnSp>
         <p:nvCxnSpPr>
-          <p:cNvPr id="36" name="Connector 35"/>
+          <p:cNvPr id="38" name="Connector 37"/>
           <p:cNvCxnSpPr/>
           <p:nvPr/>
         </p:nvCxnSpPr>
@@ -22024,7 +22341,7 @@
       </p:cxnSp>
       <p:sp>
         <p:nvSpPr>
-          <p:cNvPr id="37" name="Rectangle 36"/>
+          <p:cNvPr id="39" name="Rectangle 38"/>
           <p:cNvSpPr/>
           <p:nvPr/>
         </p:nvSpPr>
@@ -22069,7 +22386,7 @@
       </p:sp>
       <p:sp>
         <p:nvSpPr>
-          <p:cNvPr id="38" name="TextBox 37"/>
+          <p:cNvPr id="40" name="TextBox 39"/>
           <p:cNvSpPr txBox="1"/>
           <p:nvPr/>
         </p:nvSpPr>
@@ -22103,7 +22420,7 @@
       </p:sp>
       <p:sp>
         <p:nvSpPr>
-          <p:cNvPr id="39" name="TextBox 38"/>
+          <p:cNvPr id="41" name="TextBox 40"/>
           <p:cNvSpPr txBox="1"/>
           <p:nvPr/>
         </p:nvSpPr>
@@ -22137,7 +22454,7 @@
       </p:sp>
       <p:cxnSp>
         <p:nvCxnSpPr>
-          <p:cNvPr id="40" name="Connector 39"/>
+          <p:cNvPr id="42" name="Connector 41"/>
           <p:cNvCxnSpPr/>
           <p:nvPr/>
         </p:nvCxnSpPr>
@@ -22173,7 +22490,7 @@
       </p:cxnSp>
       <p:sp>
         <p:nvSpPr>
-          <p:cNvPr id="41" name="TextBox 40"/>
+          <p:cNvPr id="43" name="TextBox 42"/>
           <p:cNvSpPr txBox="1"/>
           <p:nvPr/>
         </p:nvSpPr>
@@ -22207,7 +22524,7 @@
       </p:sp>
       <p:cxnSp>
         <p:nvCxnSpPr>
-          <p:cNvPr id="42" name="Connector 41"/>
+          <p:cNvPr id="44" name="Connector 43"/>
           <p:cNvCxnSpPr/>
           <p:nvPr/>
         </p:nvCxnSpPr>
@@ -22243,7 +22560,7 @@
       </p:cxnSp>
       <p:sp>
         <p:nvSpPr>
-          <p:cNvPr id="43" name="Rectangle 42"/>
+          <p:cNvPr id="45" name="Rectangle 44"/>
           <p:cNvSpPr/>
           <p:nvPr/>
         </p:nvSpPr>
@@ -22288,7 +22605,7 @@
       </p:sp>
       <p:sp>
         <p:nvSpPr>
-          <p:cNvPr id="44" name="TextBox 43"/>
+          <p:cNvPr id="46" name="TextBox 45"/>
           <p:cNvSpPr txBox="1"/>
           <p:nvPr/>
         </p:nvSpPr>
@@ -22322,7 +22639,7 @@
       </p:sp>
       <p:sp>
         <p:nvSpPr>
-          <p:cNvPr id="45" name="TextBox 44"/>
+          <p:cNvPr id="47" name="TextBox 46"/>
           <p:cNvSpPr txBox="1"/>
           <p:nvPr/>
         </p:nvSpPr>
@@ -22356,7 +22673,7 @@
       </p:sp>
       <p:cxnSp>
         <p:nvCxnSpPr>
-          <p:cNvPr id="46" name="Connector 45"/>
+          <p:cNvPr id="48" name="Connector 47"/>
           <p:cNvCxnSpPr/>
           <p:nvPr/>
         </p:nvCxnSpPr>
@@ -22392,7 +22709,7 @@
       </p:cxnSp>
       <p:sp>
         <p:nvSpPr>
-          <p:cNvPr id="47" name="Rectangle 46"/>
+          <p:cNvPr id="49" name="Rectangle 48"/>
           <p:cNvSpPr/>
           <p:nvPr/>
         </p:nvSpPr>
@@ -22437,7 +22754,7 @@
       </p:sp>
       <p:sp>
         <p:nvSpPr>
-          <p:cNvPr id="48" name="TextBox 47"/>
+          <p:cNvPr id="50" name="TextBox 49"/>
           <p:cNvSpPr txBox="1"/>
           <p:nvPr/>
         </p:nvSpPr>
@@ -22471,7 +22788,7 @@
       </p:sp>
       <p:sp>
         <p:nvSpPr>
-          <p:cNvPr id="49" name="TextBox 48"/>
+          <p:cNvPr id="51" name="TextBox 50"/>
           <p:cNvSpPr txBox="1"/>
           <p:nvPr/>
         </p:nvSpPr>

</xml_diff>